<commit_message>
Update final report and deck: n8n trial dates after moving to the new n8n Cloud account
Co-Authored-By: Claude Sonnet 5.5 <noreply@anthropic.com>
</commit_message>
<xml_diff>
--- a/docs/final/Final_Presentation.pptx
+++ b/docs/final/Final_Presentation.pptx
@@ -3074,7 +3074,7 @@
           <a:p>
             <a:r>
               <a:rPr lang="en-US" dirty="0"/>
-              <a:t>Each task ties back to a problem example on slide 3. Run task 4 once before the demo to confirm the output. Backup: recorded outputs and exported n8n JSON, since the n8n Cloud trial ends about 9 October.</a:t>
+              <a:t>Each task ties back to a problem example on slide 3. Run task 4 once before the demo to confirm the output. Backup: recorded outputs and exported n8n JSON, in case the n8n Cloud trial (current account valid to about 16 October) or the network fails.</a:t>
             </a:r>
             <a:endParaRPr lang="en-US" dirty="0"/>
           </a:p>
@@ -9148,7 +9148,7 @@
                           <a:ea typeface="Calibri" pitchFamily="34" charset="-122"/>
                           <a:cs typeface="Calibri" pitchFamily="34" charset="-120"/>
                         </a:rPr>
-                        <a:t>No local files or embedding model; trial ends about 9 Oct</a:t>
+                        <a:t>No local files or embedding model; trial limited (current account to ~16 Oct)</a:t>
                       </a:r>
                       <a:endParaRPr lang="en-US" sz="1500" dirty="0">
                         <a:latin typeface="Calibri" charset="0"/>

</xml_diff>

<commit_message>
Use the Anthropic Console total ($4.29) for project spend in report, deck and experiment log
Co-Authored-By: Claude Sonnet 5.5 <noreply@anthropic.com>
</commit_message>
<xml_diff>
--- a/docs/final/Final_Presentation.pptx
+++ b/docs/final/Final_Presentation.pptx
@@ -2634,7 +2634,7 @@
           <a:p>
             <a:r>
               <a:rPr lang="en-US" dirty="0"/>
-              <a:t>Throughput was measured on 120 reviews and extrapolated to 1,000. Total spend estimate is $2.8 to $3.7 including runs whose cost was not recorded.</a:t>
+              <a:t>Throughput was measured on 120 reviews and extrapolated to 1,000. Total spend is $4.29 per the Anthropic Console, including runs whose cost was not logged.</a:t>
             </a:r>
             <a:endParaRPr lang="en-US" dirty="0"/>
           </a:p>
@@ -6059,7 +6059,7 @@
                 <a:ea typeface="Cambria" pitchFamily="34" charset="-122"/>
                 <a:cs typeface="Cambria" pitchFamily="34" charset="-120"/>
               </a:rPr>
-              <a:t>&lt; $4</a:t>
+              <a:t>$4.29</a:t>
             </a:r>
             <a:endParaRPr lang="en-US" sz="4400" dirty="0"/>
           </a:p>
@@ -6098,7 +6098,7 @@
                 <a:ea typeface="Calibri" pitchFamily="34" charset="-122"/>
                 <a:cs typeface="Calibri" pitchFamily="34" charset="-120"/>
               </a:rPr>
-              <a:t>estimated total Claude spend for the whole project (budget $5)</a:t>
+              <a:t>total Claude spend for the whole project (budget $5)</a:t>
             </a:r>
             <a:endParaRPr lang="en-US" sz="1300" dirty="0"/>
           </a:p>

</xml_diff>

<commit_message>
Add demo app screenshots to the final report (Figures B5, B6) and deck (slide 15)
Co-Authored-By: Claude Sonnet 5.5 <noreply@anthropic.com>
</commit_message>
<xml_diff>
--- a/docs/final/Final_Presentation.pptx
+++ b/docs/final/Final_Presentation.pptx
@@ -25,9 +25,10 @@
     <p:sldId id="273" r:id="rId19"/>
     <p:sldId id="274" r:id="rId20"/>
     <p:sldId id="275" r:id="rId21"/>
+    <p:sldId id="276" r:id="rId22"/>
   </p:sldIdLst>
   <p:notesMasterIdLst>
-    <p:notesMasterId r:id="rId22"/>
+    <p:notesMasterId r:id="rId23"/>
   </p:notesMasterIdLst>
   <p:sldSz cx="12192000" cy="6858000"/>
   <p:notesSz cx="6858000" cy="12192000"/>
@@ -2987,7 +2988,7 @@
           <a:p>
             <a:r>
               <a:rPr lang="en-US" dirty="0"/>
-              <a:t>Pick two or three to tell as short stories: the sorted dataset, the false 'sent', and the neutral-class ceiling.</a:t>
+              <a:t>Live screenshots of the public Space. Left: the live tab with a German review that was never delivered; negative, shipping, 1 star, reply drafted in German, status pending human review, judge scores 4 on all four criteria. Right: the spike tab with the same four alerts as the Slack message (z 12.56, 9.80, 4.54, 4.26). The garbled character in the pasted review is a copy and paste artefact; the source data and the reply are correct.</a:t>
             </a:r>
             <a:endParaRPr lang="en-US" dirty="0"/>
           </a:p>
@@ -3075,7 +3076,7 @@
           <a:p>
             <a:r>
               <a:rPr lang="en-US" dirty="0"/>
-              <a:t>Read the table top to bottom. The two honest misses are three-way sentiment and star error; both trace back to noisy star labels.</a:t>
+              <a:t>Pick two or three to tell as short stories: the sorted dataset, the false 'sent', and the neutral-class ceiling.</a:t>
             </a:r>
             <a:endParaRPr lang="en-US" dirty="0"/>
           </a:p>
@@ -3163,7 +3164,7 @@
           <a:p>
             <a:r>
               <a:rPr lang="en-US" dirty="0"/>
-              <a:t>Each task ties back to a problem example on slide 3. Run task 4 once before the demo to confirm the output. Backup: recorded outputs and exported n8n JSON, in case the n8n Cloud trial (current account valid to about 16 October) or the network fails. If n8n fails on the day, the Hugging Face Space still runs the same classification and reply drafting.</a:t>
+              <a:t>Read the table top to bottom. The two honest misses are three-way sentiment and star error; both trace back to noisy star labels.</a:t>
             </a:r>
             <a:endParaRPr lang="en-US" dirty="0"/>
           </a:p>
@@ -3251,7 +3252,7 @@
           <a:p>
             <a:r>
               <a:rPr lang="en-US" dirty="0"/>
-              <a:t>Limitations first, then what we would do with more time.</a:t>
+              <a:t>Each task ties back to a problem example on slide 3. Run task 4 once before the demo to confirm the output. Backup: recorded outputs and exported n8n JSON, in case the n8n Cloud trial (current account valid to about 16 October) or the network fails. If n8n fails on the day, the Hugging Face Space still runs the same classification and reply drafting.</a:t>
             </a:r>
             <a:endParaRPr lang="en-US" dirty="0"/>
           </a:p>
@@ -3339,7 +3340,7 @@
           <a:p>
             <a:r>
               <a:rPr lang="en-US" dirty="0"/>
-              <a:t>The 2 minutes per review is an illustration, not a measurement. Replace it with the team's own figure before presenting.</a:t>
+              <a:t>Limitations first, then what we would do with more time.</a:t>
             </a:r>
             <a:endParaRPr lang="en-US" dirty="0"/>
           </a:p>
@@ -3515,7 +3516,7 @@
           <a:p>
             <a:r>
               <a:rPr lang="en-US" dirty="0"/>
-              <a:t/>
+              <a:t>The 2 minutes per review is an illustration, not a measurement. Replace it with the team's own figure before presenting.</a:t>
             </a:r>
             <a:endParaRPr lang="en-US" dirty="0"/>
           </a:p>
@@ -3539,6 +3540,94 @@
             <a:fld id="{F7021451-1387-4CA6-816F-3879F97B5CBC}" type="slidenum">
               <a:rPr lang="en-US"/>
               <a:t>20</a:t>
+            </a:fld>
+            <a:endParaRPr lang="en-US"/>
+          </a:p>
+        </p:txBody>
+      </p:sp>
+    </p:spTree>
+    <p:extLst>
+      <p:ext uri="{BB962C8B-B14F-4D97-AF65-F5344CB8AC3E}">
+        <p14:creationId xmlns:p14="http://schemas.microsoft.com/office/powerpoint/2010/main" val="1024086991"/>
+      </p:ext>
+    </p:extLst>
+  </p:cSld>
+  <p:clrMapOvr>
+    <a:masterClrMapping/>
+  </p:clrMapOvr>
+</p:notes>
+</file>
+
+<file path=ppt/notesSlides/notesSlide21.xml><?xml version="1.0" encoding="utf-8"?>
+<p:notes xmlns:a="http://schemas.openxmlformats.org/drawingml/2006/main" xmlns:r="http://schemas.openxmlformats.org/officeDocument/2006/relationships" xmlns:p="http://schemas.openxmlformats.org/presentationml/2006/main">
+  <p:cSld>
+    <p:spTree>
+      <p:nvGrpSpPr>
+        <p:cNvPr id="1" name=""/>
+        <p:cNvGrpSpPr/>
+        <p:nvPr/>
+      </p:nvGrpSpPr>
+      <p:grpSpPr>
+        <a:xfrm>
+          <a:off x="0" y="0"/>
+          <a:ext cx="0" cy="0"/>
+          <a:chOff x="0" y="0"/>
+          <a:chExt cx="0" cy="0"/>
+        </a:xfrm>
+      </p:grpSpPr>
+      <p:sp>
+        <p:nvSpPr>
+          <p:cNvPr id="2" name="Slide Image Placeholder 1"/>
+          <p:cNvSpPr>
+            <a:spLocks noGrp="1" noRot="1" noChangeAspect="1"/>
+          </p:cNvSpPr>
+          <p:nvPr>
+            <p:ph type="sldImg"/>
+          </p:nvPr>
+        </p:nvSpPr>
+        <p:spPr/>
+      </p:sp>
+      <p:sp>
+        <p:nvSpPr>
+          <p:cNvPr id="3" name="Notes Placeholder 2"/>
+          <p:cNvSpPr>
+            <a:spLocks noGrp="1"/>
+          </p:cNvSpPr>
+          <p:nvPr>
+            <p:ph type="body" idx="1"/>
+          </p:nvPr>
+        </p:nvSpPr>
+        <p:spPr/>
+        <p:txBody>
+          <a:bodyPr/>
+          <a:lstStyle/>
+          <a:p>
+            <a:r>
+              <a:rPr lang="en-US" dirty="0"/>
+              <a:t/>
+            </a:r>
+            <a:endParaRPr lang="en-US" dirty="0"/>
+          </a:p>
+        </p:txBody>
+      </p:sp>
+      <p:sp>
+        <p:nvSpPr>
+          <p:cNvPr id="4" name="Slide Number Placeholder 3"/>
+          <p:cNvSpPr>
+            <a:spLocks noGrp="1"/>
+          </p:cNvSpPr>
+          <p:nvPr>
+            <p:ph type="sldNum" sz="quarter" idx="10"/>
+          </p:nvPr>
+        </p:nvSpPr>
+        <p:spPr/>
+        <p:txBody>
+          <a:bodyPr/>
+          <a:lstStyle/>
+          <a:p>
+            <a:fld id="{F7021451-1387-4CA6-816F-3879F97B5CBC}" type="slidenum">
+              <a:rPr lang="en-US"/>
+              <a:t>21</a:t>
             </a:fld>
             <a:endParaRPr lang="en-US"/>
           </a:p>
@@ -9030,7 +9119,7 @@
                 <a:ea typeface="Calibri" pitchFamily="34" charset="-122"/>
                 <a:cs typeface="Calibri" pitchFamily="34" charset="-120"/>
               </a:rPr>
-              <a:t>METHODS TRIED AND CHALLENGES</a:t>
+              <a:t>DEMO APP</a:t>
             </a:r>
             <a:endParaRPr lang="en-US" sz="1200" dirty="0"/>
           </a:p>
@@ -9069,7 +9158,7 @@
                 <a:ea typeface="Cambria" pitchFamily="34" charset="-122"/>
                 <a:cs typeface="Cambria" pitchFamily="34" charset="-120"/>
               </a:rPr>
-              <a:t>What went wrong along the way, and how we fixed it</a:t>
+              <a:t>The demo app in action</a:t>
             </a:r>
             <a:endParaRPr lang="en-US" sz="3000" dirty="0"/>
           </a:p>
@@ -9114,9 +9203,332 @@
           </a:p>
         </p:txBody>
       </p:sp>
+      <p:pic>
+        <p:nvPicPr>
+          <p:cNvPr id="5" name="Image 0" descr="C:\Users\HP\AppData\Local\Temp\claude\E--Capstone-Project\e1198f5c-9597-4f9e-97a5-53c83e2ccc77\scratchpad\report\space_live.png">    </p:cNvPr>
+          <p:cNvPicPr>
+            <a:picLocks noChangeAspect="1"/>
+          </p:cNvPicPr>
+          <p:nvPr/>
+        </p:nvPicPr>
+        <p:blipFill>
+          <a:blip r:embed="rId1"/>
+          <a:stretch>
+            <a:fillRect/>
+          </a:stretch>
+        </p:blipFill>
+        <p:spPr>
+          <a:xfrm>
+            <a:off x="548640" y="1463040"/>
+            <a:ext cx="5368413" cy="4160520"/>
+          </a:xfrm>
+          <a:prstGeom prst="rect">
+            <a:avLst/>
+          </a:prstGeom>
+        </p:spPr>
+      </p:pic>
+      <p:pic>
+        <p:nvPicPr>
+          <p:cNvPr id="6" name="Image 1" descr="C:\Users\HP\AppData\Local\Temp\claude\E--Capstone-Project\e1198f5c-9597-4f9e-97a5-53c83e2ccc77\scratchpad\report\space_spikes.png">    </p:cNvPr>
+          <p:cNvPicPr>
+            <a:picLocks noChangeAspect="1"/>
+          </p:cNvPicPr>
+          <p:nvPr/>
+        </p:nvPicPr>
+        <p:blipFill>
+          <a:blip r:embed="rId2"/>
+          <a:stretch>
+            <a:fillRect/>
+          </a:stretch>
+        </p:blipFill>
+        <p:spPr>
+          <a:xfrm>
+            <a:off x="6191373" y="1463040"/>
+            <a:ext cx="5722205" cy="4160520"/>
+          </a:xfrm>
+          <a:prstGeom prst="rect">
+            <a:avLst/>
+          </a:prstGeom>
+        </p:spPr>
+      </p:pic>
+      <p:sp>
+        <p:nvSpPr>
+          <p:cNvPr id="7" name="Text 3"/>
+          <p:cNvSpPr txBox="1"/>
+          <p:nvPr/>
+        </p:nvSpPr>
+        <p:spPr>
+          <a:xfrm>
+            <a:off x="548640" y="5715000"/>
+            <a:ext cx="5368413" cy="548640"/>
+          </a:xfrm>
+          <a:prstGeom prst="rect">
+            <a:avLst/>
+          </a:prstGeom>
+          <a:noFill/>
+          <a:ln/>
+        </p:spPr>
+        <p:txBody>
+          <a:bodyPr wrap="square" lIns="0" tIns="0" rIns="0" bIns="0" rtlCol="0" anchor="t"/>
+          <a:lstStyle/>
+          <a:p>
+            <a:pPr indent="0" marL="0">
+              <a:buNone/>
+            </a:pPr>
+            <a:r>
+              <a:rPr lang="en-US" sz="1200" dirty="0">
+                <a:solidFill>
+                  <a:srgbClr val="5A6470"/>
+                </a:solidFill>
+                <a:latin typeface="Calibri" pitchFamily="34" charset="0"/>
+                <a:ea typeface="Calibri" pitchFamily="34" charset="-122"/>
+                <a:cs typeface="Calibri" pitchFamily="34" charset="-120"/>
+              </a:rPr>
+              <a:t>Your own review: a pasted German review becomes sentiment, topic, issue, a German reply and judge scores</a:t>
+            </a:r>
+            <a:endParaRPr lang="en-US" sz="1200" dirty="0"/>
+          </a:p>
+        </p:txBody>
+      </p:sp>
+      <p:sp>
+        <p:nvSpPr>
+          <p:cNvPr id="8" name="Text 4"/>
+          <p:cNvSpPr txBox="1"/>
+          <p:nvPr/>
+        </p:nvSpPr>
+        <p:spPr>
+          <a:xfrm>
+            <a:off x="6191373" y="5715000"/>
+            <a:ext cx="5722205" cy="548640"/>
+          </a:xfrm>
+          <a:prstGeom prst="rect">
+            <a:avLst/>
+          </a:prstGeom>
+          <a:noFill/>
+          <a:ln/>
+        </p:spPr>
+        <p:txBody>
+          <a:bodyPr wrap="square" lIns="0" tIns="0" rIns="0" bIns="0" rtlCol="0" anchor="t"/>
+          <a:lstStyle/>
+          <a:p>
+            <a:pPr indent="0" marL="0">
+              <a:buNone/>
+            </a:pPr>
+            <a:r>
+              <a:rPr lang="en-US" sz="1200" dirty="0">
+                <a:solidFill>
+                  <a:srgbClr val="5A6470"/>
+                </a:solidFill>
+                <a:latin typeface="Calibri" pitchFamily="34" charset="0"/>
+                <a:ea typeface="Calibri" pitchFamily="34" charset="-122"/>
+                <a:cs typeface="Calibri" pitchFamily="34" charset="-120"/>
+              </a:rPr>
+              <a:t>Spike detection: the same four alerts as workflow 04, with adjustable thresholds</a:t>
+            </a:r>
+            <a:endParaRPr lang="en-US" sz="1200" dirty="0"/>
+          </a:p>
+        </p:txBody>
+      </p:sp>
+      <p:sp>
+        <p:nvSpPr>
+          <p:cNvPr id="25" name="Slide Number Placeholder 0"/>
+          <p:cNvSpPr>
+            <a:spLocks noGrp="1"/>
+          </p:cNvSpPr>
+          <p:nvPr>
+            <p:ph type="sldNum" sz="quarter" idx="4294967295"/>
+          </p:nvPr>
+        </p:nvSpPr>
+        <p:spPr>
+          <a:xfrm>
+            <a:off x="11155680" y="6446520"/>
+            <a:ext cx="548640" cy="274320"/>
+          </a:xfrm>
+          <a:prstGeom prst="rect">
+            <a:avLst/>
+          </a:prstGeom>
+          <a:extLst>
+            <a:ext uri="{C572A759-6A51-4108-AA02-DFA0A04FC94B}">
+              <ma14:wrappingTextBoxFlag xmlns:ma14="http://schemas.microsoft.com/office/mac/drawingml/2011/main" val="0"/>
+            </a:ext>
+          </a:extLst>
+        </p:spPr>
+        <p:txBody>
+          <a:bodyPr/>
+          <a:lstStyle>
+            <a:lvl1pPr>
+              <a:defRPr sz="1000">
+                <a:solidFill>
+                  <a:srgbClr val="5A6470"/>
+                </a:solidFill>
+                <a:latin typeface="Calibri"/>
+                <a:ea typeface="Calibri"/>
+                <a:cs typeface="Calibri"/>
+              </a:defRPr>
+            </a:lvl1pPr>
+          </a:lstStyle>
+          <a:p>
+            <a:pPr algn="r"/>
+            <a:fld id="{F7021451-1387-4CA6-816F-3879F97B5CBC}" type="slidenum">
+              <a:rPr b="0" lang="en-US"/>
+              <a:t>15</a:t>
+            </a:fld>
+            <a:endParaRPr lang="en-US"/>
+          </a:p>
+        </p:txBody>
+      </p:sp>
+    </p:spTree>
+  </p:cSld>
+  <p:clrMapOvr>
+    <a:masterClrMapping/>
+  </p:clrMapOvr>
+</p:sld>
+</file>
+
+<file path=ppt/slides/slide16.xml><?xml version="1.0" encoding="utf-8"?>
+<p:sld xmlns:a="http://schemas.openxmlformats.org/drawingml/2006/main" xmlns:r="http://schemas.openxmlformats.org/officeDocument/2006/relationships" xmlns:p="http://schemas.openxmlformats.org/presentationml/2006/main">
+  <p:cSld name="Slide 16">
+    <p:bg>
+      <p:bgPr>
+        <a:solidFill>
+          <a:srgbClr val="FFFFFF"/>
+        </a:solidFill>
+      </p:bgPr>
+    </p:bg>
+    <p:spTree>
+      <p:nvGrpSpPr>
+        <p:cNvPr id="1" name=""/>
+        <p:cNvGrpSpPr/>
+        <p:nvPr/>
+      </p:nvGrpSpPr>
+      <p:grpSpPr>
+        <a:xfrm>
+          <a:off x="0" y="0"/>
+          <a:ext cx="0" cy="0"/>
+          <a:chOff x="0" y="0"/>
+          <a:chExt cx="0" cy="0"/>
+        </a:xfrm>
+      </p:grpSpPr>
+      <p:sp>
+        <p:nvSpPr>
+          <p:cNvPr id="2" name="Text 0"/>
+          <p:cNvSpPr txBox="1"/>
+          <p:nvPr/>
+        </p:nvSpPr>
+        <p:spPr>
+          <a:xfrm>
+            <a:off x="548640" y="320040"/>
+            <a:ext cx="8229600" cy="274320"/>
+          </a:xfrm>
+          <a:prstGeom prst="rect">
+            <a:avLst/>
+          </a:prstGeom>
+          <a:noFill/>
+          <a:ln/>
+        </p:spPr>
+        <p:txBody>
+          <a:bodyPr wrap="square" lIns="0" tIns="0" rIns="0" bIns="0" rtlCol="0" anchor="ctr"/>
+          <a:lstStyle/>
+          <a:p>
+            <a:pPr indent="0" marL="0">
+              <a:buNone/>
+            </a:pPr>
+            <a:r>
+              <a:rPr lang="en-US" sz="1200" b="1" spc="200" kern="0" dirty="0">
+                <a:solidFill>
+                  <a:srgbClr val="2A9D8F"/>
+                </a:solidFill>
+                <a:latin typeface="Calibri" pitchFamily="34" charset="0"/>
+                <a:ea typeface="Calibri" pitchFamily="34" charset="-122"/>
+                <a:cs typeface="Calibri" pitchFamily="34" charset="-120"/>
+              </a:rPr>
+              <a:t>METHODS TRIED AND CHALLENGES</a:t>
+            </a:r>
+            <a:endParaRPr lang="en-US" sz="1200" dirty="0"/>
+          </a:p>
+        </p:txBody>
+      </p:sp>
+      <p:sp>
+        <p:nvSpPr>
+          <p:cNvPr id="3" name="Text 1"/>
+          <p:cNvSpPr txBox="1"/>
+          <p:nvPr/>
+        </p:nvSpPr>
+        <p:spPr>
+          <a:xfrm>
+            <a:off x="548640" y="594360"/>
+            <a:ext cx="11064240" cy="777240"/>
+          </a:xfrm>
+          <a:prstGeom prst="rect">
+            <a:avLst/>
+          </a:prstGeom>
+          <a:noFill/>
+          <a:ln/>
+        </p:spPr>
+        <p:txBody>
+          <a:bodyPr wrap="square" lIns="0" tIns="0" rIns="0" bIns="0" rtlCol="0" anchor="t"/>
+          <a:lstStyle/>
+          <a:p>
+            <a:pPr indent="0" marL="0">
+              <a:buNone/>
+            </a:pPr>
+            <a:r>
+              <a:rPr lang="en-US" sz="3000" b="1" dirty="0">
+                <a:solidFill>
+                  <a:srgbClr val="1F3A5F"/>
+                </a:solidFill>
+                <a:latin typeface="Cambria" pitchFamily="34" charset="0"/>
+                <a:ea typeface="Cambria" pitchFamily="34" charset="-122"/>
+                <a:cs typeface="Cambria" pitchFamily="34" charset="-120"/>
+              </a:rPr>
+              <a:t>What went wrong along the way, and how we fixed it</a:t>
+            </a:r>
+            <a:endParaRPr lang="en-US" sz="3000" dirty="0"/>
+          </a:p>
+        </p:txBody>
+      </p:sp>
+      <p:sp>
+        <p:nvSpPr>
+          <p:cNvPr id="4" name="Text 2"/>
+          <p:cNvSpPr txBox="1"/>
+          <p:nvPr/>
+        </p:nvSpPr>
+        <p:spPr>
+          <a:xfrm>
+            <a:off x="548640" y="6446520"/>
+            <a:ext cx="7315200" cy="274320"/>
+          </a:xfrm>
+          <a:prstGeom prst="rect">
+            <a:avLst/>
+          </a:prstGeom>
+          <a:noFill/>
+          <a:ln/>
+        </p:spPr>
+        <p:txBody>
+          <a:bodyPr wrap="square" lIns="0" tIns="0" rIns="0" bIns="0" rtlCol="0" anchor="ctr"/>
+          <a:lstStyle/>
+          <a:p>
+            <a:pPr indent="0" marL="0">
+              <a:buNone/>
+            </a:pPr>
+            <a:r>
+              <a:rPr lang="en-US" sz="1000" dirty="0">
+                <a:solidFill>
+                  <a:srgbClr val="5A6470"/>
+                </a:solidFill>
+                <a:latin typeface="Calibri" pitchFamily="34" charset="0"/>
+                <a:ea typeface="Calibri" pitchFamily="34" charset="-122"/>
+                <a:cs typeface="Calibri" pitchFamily="34" charset="-120"/>
+              </a:rPr>
+              <a:t>Group 5  |  Customer Review Insights &amp; Response Generator</a:t>
+            </a:r>
+            <a:endParaRPr lang="en-US" sz="1000" dirty="0"/>
+          </a:p>
+        </p:txBody>
+      </p:sp>
       <p:graphicFrame>
         <p:nvGraphicFramePr>
-          <p:cNvPr id="16" name="Table 0"/>
+          <p:cNvPr id="17" name="Table 0"/>
           <p:cNvGraphicFramePr>
             <a:graphicFrameLocks noGrp="1"/>
           </p:cNvGraphicFramePr>
@@ -11041,7 +11453,7 @@
             <a:pPr algn="r"/>
             <a:fld id="{F7021451-1387-4CA6-816F-3879F97B5CBC}" type="slidenum">
               <a:rPr b="0" lang="en-US"/>
-              <a:t>15</a:t>
+              <a:t>16</a:t>
             </a:fld>
             <a:endParaRPr lang="en-US"/>
           </a:p>
@@ -11055,9 +11467,9 @@
 </p:sld>
 </file>
 
-<file path=ppt/slides/slide16.xml><?xml version="1.0" encoding="utf-8"?>
+<file path=ppt/slides/slide17.xml><?xml version="1.0" encoding="utf-8"?>
 <p:sld xmlns:a="http://schemas.openxmlformats.org/drawingml/2006/main" xmlns:r="http://schemas.openxmlformats.org/officeDocument/2006/relationships" xmlns:p="http://schemas.openxmlformats.org/presentationml/2006/main">
-  <p:cSld name="Slide 16">
+  <p:cSld name="Slide 17">
     <p:bg>
       <p:bgPr>
         <a:solidFill>
@@ -11198,7 +11610,7 @@
       </p:sp>
       <p:graphicFrame>
         <p:nvGraphicFramePr>
-          <p:cNvPr id="17" name="Table 0"/>
+          <p:cNvPr id="18" name="Table 0"/>
           <p:cNvGraphicFramePr>
             <a:graphicFrameLocks noGrp="1"/>
           </p:cNvGraphicFramePr>
@@ -12750,1243 +13162,6 @@
             <a:pPr algn="r"/>
             <a:fld id="{F7021451-1387-4CA6-816F-3879F97B5CBC}" type="slidenum">
               <a:rPr b="0" lang="en-US"/>
-              <a:t>16</a:t>
-            </a:fld>
-            <a:endParaRPr lang="en-US"/>
-          </a:p>
-        </p:txBody>
-      </p:sp>
-    </p:spTree>
-  </p:cSld>
-  <p:clrMapOvr>
-    <a:masterClrMapping/>
-  </p:clrMapOvr>
-</p:sld>
-</file>
-
-<file path=ppt/slides/slide17.xml><?xml version="1.0" encoding="utf-8"?>
-<p:sld xmlns:a="http://schemas.openxmlformats.org/drawingml/2006/main" xmlns:r="http://schemas.openxmlformats.org/officeDocument/2006/relationships" xmlns:p="http://schemas.openxmlformats.org/presentationml/2006/main">
-  <p:cSld name="Slide 17">
-    <p:bg>
-      <p:bgPr>
-        <a:solidFill>
-          <a:srgbClr val="FFFFFF"/>
-        </a:solidFill>
-      </p:bgPr>
-    </p:bg>
-    <p:spTree>
-      <p:nvGrpSpPr>
-        <p:cNvPr id="1" name=""/>
-        <p:cNvGrpSpPr/>
-        <p:nvPr/>
-      </p:nvGrpSpPr>
-      <p:grpSpPr>
-        <a:xfrm>
-          <a:off x="0" y="0"/>
-          <a:ext cx="0" cy="0"/>
-          <a:chOff x="0" y="0"/>
-          <a:chExt cx="0" cy="0"/>
-        </a:xfrm>
-      </p:grpSpPr>
-      <p:sp>
-        <p:nvSpPr>
-          <p:cNvPr id="2" name="Text 0"/>
-          <p:cNvSpPr txBox="1"/>
-          <p:nvPr/>
-        </p:nvSpPr>
-        <p:spPr>
-          <a:xfrm>
-            <a:off x="548640" y="320040"/>
-            <a:ext cx="8229600" cy="274320"/>
-          </a:xfrm>
-          <a:prstGeom prst="rect">
-            <a:avLst/>
-          </a:prstGeom>
-          <a:noFill/>
-          <a:ln/>
-        </p:spPr>
-        <p:txBody>
-          <a:bodyPr wrap="square" lIns="0" tIns="0" rIns="0" bIns="0" rtlCol="0" anchor="ctr"/>
-          <a:lstStyle/>
-          <a:p>
-            <a:pPr indent="0" marL="0">
-              <a:buNone/>
-            </a:pPr>
-            <a:r>
-              <a:rPr lang="en-US" sz="1200" b="1" spc="200" kern="0" dirty="0">
-                <a:solidFill>
-                  <a:srgbClr val="2A9D8F"/>
-                </a:solidFill>
-                <a:latin typeface="Calibri" pitchFamily="34" charset="0"/>
-                <a:ea typeface="Calibri" pitchFamily="34" charset="-122"/>
-                <a:cs typeface="Calibri" pitchFamily="34" charset="-120"/>
-              </a:rPr>
-              <a:t>LIVE DEMO</a:t>
-            </a:r>
-            <a:endParaRPr lang="en-US" sz="1200" dirty="0"/>
-          </a:p>
-        </p:txBody>
-      </p:sp>
-      <p:sp>
-        <p:nvSpPr>
-          <p:cNvPr id="3" name="Text 1"/>
-          <p:cNvSpPr txBox="1"/>
-          <p:nvPr/>
-        </p:nvSpPr>
-        <p:spPr>
-          <a:xfrm>
-            <a:off x="548640" y="594360"/>
-            <a:ext cx="11064240" cy="777240"/>
-          </a:xfrm>
-          <a:prstGeom prst="rect">
-            <a:avLst/>
-          </a:prstGeom>
-          <a:noFill/>
-          <a:ln/>
-        </p:spPr>
-        <p:txBody>
-          <a:bodyPr wrap="square" lIns="0" tIns="0" rIns="0" bIns="0" rtlCol="0" anchor="t"/>
-          <a:lstStyle/>
-          <a:p>
-            <a:pPr indent="0" marL="0">
-              <a:buNone/>
-            </a:pPr>
-            <a:r>
-              <a:rPr lang="en-US" sz="3000" b="1" dirty="0">
-                <a:solidFill>
-                  <a:srgbClr val="1F3A5F"/>
-                </a:solidFill>
-                <a:latin typeface="Cambria" pitchFamily="34" charset="0"/>
-                <a:ea typeface="Cambria" pitchFamily="34" charset="-122"/>
-                <a:cs typeface="Cambria" pitchFamily="34" charset="-120"/>
-              </a:rPr>
-              <a:t>Demo plan: five tasks, from easy to hardest</a:t>
-            </a:r>
-            <a:endParaRPr lang="en-US" sz="3000" dirty="0"/>
-          </a:p>
-        </p:txBody>
-      </p:sp>
-      <p:sp>
-        <p:nvSpPr>
-          <p:cNvPr id="4" name="Text 2"/>
-          <p:cNvSpPr txBox="1"/>
-          <p:nvPr/>
-        </p:nvSpPr>
-        <p:spPr>
-          <a:xfrm>
-            <a:off x="548640" y="6446520"/>
-            <a:ext cx="7315200" cy="274320"/>
-          </a:xfrm>
-          <a:prstGeom prst="rect">
-            <a:avLst/>
-          </a:prstGeom>
-          <a:noFill/>
-          <a:ln/>
-        </p:spPr>
-        <p:txBody>
-          <a:bodyPr wrap="square" lIns="0" tIns="0" rIns="0" bIns="0" rtlCol="0" anchor="ctr"/>
-          <a:lstStyle/>
-          <a:p>
-            <a:pPr indent="0" marL="0">
-              <a:buNone/>
-            </a:pPr>
-            <a:r>
-              <a:rPr lang="en-US" sz="1000" dirty="0">
-                <a:solidFill>
-                  <a:srgbClr val="5A6470"/>
-                </a:solidFill>
-                <a:latin typeface="Calibri" pitchFamily="34" charset="0"/>
-                <a:ea typeface="Calibri" pitchFamily="34" charset="-122"/>
-                <a:cs typeface="Calibri" pitchFamily="34" charset="-120"/>
-              </a:rPr>
-              <a:t>Group 5  |  Customer Review Insights &amp; Response Generator</a:t>
-            </a:r>
-            <a:endParaRPr lang="en-US" sz="1000" dirty="0"/>
-          </a:p>
-        </p:txBody>
-      </p:sp>
-      <p:sp>
-        <p:nvSpPr>
-          <p:cNvPr id="5" name="Shape 3"/>
-          <p:cNvSpPr/>
-          <p:nvPr/>
-        </p:nvSpPr>
-        <p:spPr>
-          <a:xfrm>
-            <a:off x="548640" y="1554480"/>
-            <a:ext cx="11064240" cy="804672"/>
-          </a:xfrm>
-          <a:prstGeom prst="roundRect">
-            <a:avLst>
-              <a:gd name="adj" fmla="val 11364"/>
-            </a:avLst>
-          </a:prstGeom>
-          <a:solidFill>
-            <a:srgbClr val="EEF2F7"/>
-          </a:solidFill>
-          <a:ln w="12700">
-            <a:solidFill>
-              <a:srgbClr val="EEF2F7"/>
-            </a:solidFill>
-            <a:prstDash val="solid"/>
-          </a:ln>
-        </p:spPr>
-      </p:sp>
-      <p:sp>
-        <p:nvSpPr>
-          <p:cNvPr id="6" name="Shape 4"/>
-          <p:cNvSpPr/>
-          <p:nvPr/>
-        </p:nvSpPr>
-        <p:spPr>
-          <a:xfrm>
-            <a:off x="731520" y="1682496"/>
-            <a:ext cx="548640" cy="548640"/>
-          </a:xfrm>
-          <a:prstGeom prst="ellipse">
-            <a:avLst/>
-          </a:prstGeom>
-          <a:solidFill>
-            <a:srgbClr val="2A9D8F"/>
-          </a:solidFill>
-          <a:ln w="12700">
-            <a:solidFill>
-              <a:srgbClr val="2A9D8F"/>
-            </a:solidFill>
-            <a:prstDash val="solid"/>
-          </a:ln>
-        </p:spPr>
-      </p:sp>
-      <p:sp>
-        <p:nvSpPr>
-          <p:cNvPr id="7" name="Text 5"/>
-          <p:cNvSpPr txBox="1"/>
-          <p:nvPr/>
-        </p:nvSpPr>
-        <p:spPr>
-          <a:xfrm>
-            <a:off x="731520" y="1682496"/>
-            <a:ext cx="548640" cy="548640"/>
-          </a:xfrm>
-          <a:prstGeom prst="rect">
-            <a:avLst/>
-          </a:prstGeom>
-          <a:noFill/>
-          <a:ln/>
-        </p:spPr>
-        <p:txBody>
-          <a:bodyPr wrap="square" lIns="0" tIns="0" rIns="0" bIns="0" rtlCol="0" anchor="ctr"/>
-          <a:lstStyle/>
-          <a:p>
-            <a:pPr algn="ctr" indent="0" marL="0">
-              <a:buNone/>
-            </a:pPr>
-            <a:r>
-              <a:rPr lang="en-US" sz="1800" b="1" dirty="0">
-                <a:solidFill>
-                  <a:srgbClr val="FFFFFF"/>
-                </a:solidFill>
-                <a:latin typeface="Cambria" pitchFamily="34" charset="0"/>
-                <a:ea typeface="Cambria" pitchFamily="34" charset="-122"/>
-                <a:cs typeface="Cambria" pitchFamily="34" charset="-120"/>
-              </a:rPr>
-              <a:t>1</a:t>
-            </a:r>
-            <a:endParaRPr lang="en-US" sz="1800" dirty="0"/>
-          </a:p>
-        </p:txBody>
-      </p:sp>
-      <p:sp>
-        <p:nvSpPr>
-          <p:cNvPr id="8" name="Text 6"/>
-          <p:cNvSpPr txBox="1"/>
-          <p:nvPr/>
-        </p:nvSpPr>
-        <p:spPr>
-          <a:xfrm>
-            <a:off x="1508760" y="1554480"/>
-            <a:ext cx="1280160" cy="804672"/>
-          </a:xfrm>
-          <a:prstGeom prst="rect">
-            <a:avLst/>
-          </a:prstGeom>
-          <a:noFill/>
-          <a:ln/>
-        </p:spPr>
-        <p:txBody>
-          <a:bodyPr wrap="square" lIns="0" tIns="0" rIns="0" bIns="0" rtlCol="0" anchor="ctr"/>
-          <a:lstStyle/>
-          <a:p>
-            <a:pPr indent="0" marL="0">
-              <a:buNone/>
-            </a:pPr>
-            <a:r>
-              <a:rPr lang="en-US" sz="1500" b="1" dirty="0">
-                <a:solidFill>
-                  <a:srgbClr val="1F3A5F"/>
-                </a:solidFill>
-                <a:latin typeface="Cambria" pitchFamily="34" charset="0"/>
-                <a:ea typeface="Cambria" pitchFamily="34" charset="-122"/>
-                <a:cs typeface="Cambria" pitchFamily="34" charset="-120"/>
-              </a:rPr>
-              <a:t>Easy</a:t>
-            </a:r>
-            <a:endParaRPr lang="en-US" sz="1500" dirty="0"/>
-          </a:p>
-        </p:txBody>
-      </p:sp>
-      <p:sp>
-        <p:nvSpPr>
-          <p:cNvPr id="9" name="Text 7"/>
-          <p:cNvSpPr txBox="1"/>
-          <p:nvPr/>
-        </p:nvSpPr>
-        <p:spPr>
-          <a:xfrm>
-            <a:off x="2834640" y="1554480"/>
-            <a:ext cx="5760720" cy="804672"/>
-          </a:xfrm>
-          <a:prstGeom prst="rect">
-            <a:avLst/>
-          </a:prstGeom>
-          <a:noFill/>
-          <a:ln/>
-        </p:spPr>
-        <p:txBody>
-          <a:bodyPr wrap="square" lIns="0" tIns="0" rIns="0" bIns="0" rtlCol="0" anchor="ctr"/>
-          <a:lstStyle/>
-          <a:p>
-            <a:pPr indent="0" marL="0">
-              <a:buNone/>
-            </a:pPr>
-            <a:r>
-              <a:rPr lang="en-US" sz="1400" dirty="0">
-                <a:solidFill>
-                  <a:srgbClr val="1B2733"/>
-                </a:solidFill>
-                <a:latin typeface="Calibri" pitchFamily="34" charset="0"/>
-                <a:ea typeface="Calibri" pitchFamily="34" charset="-122"/>
-                <a:cs typeface="Calibri" pitchFamily="34" charset="-120"/>
-              </a:rPr>
-              <a:t>Classify one review: “arrived late and the box was crushed”</a:t>
-            </a:r>
-            <a:endParaRPr lang="en-US" sz="1400" dirty="0"/>
-          </a:p>
-        </p:txBody>
-      </p:sp>
-      <p:sp>
-        <p:nvSpPr>
-          <p:cNvPr id="10" name="Text 8"/>
-          <p:cNvSpPr txBox="1"/>
-          <p:nvPr/>
-        </p:nvSpPr>
-        <p:spPr>
-          <a:xfrm>
-            <a:off x="8686800" y="1554480"/>
-            <a:ext cx="2834640" cy="804672"/>
-          </a:xfrm>
-          <a:prstGeom prst="rect">
-            <a:avLst/>
-          </a:prstGeom>
-          <a:noFill/>
-          <a:ln/>
-        </p:spPr>
-        <p:txBody>
-          <a:bodyPr wrap="square" lIns="0" tIns="0" rIns="0" bIns="0" rtlCol="0" anchor="ctr"/>
-          <a:lstStyle/>
-          <a:p>
-            <a:pPr indent="0" marL="0">
-              <a:buNone/>
-            </a:pPr>
-            <a:r>
-              <a:rPr lang="en-US" sz="1300" i="1" dirty="0">
-                <a:solidFill>
-                  <a:srgbClr val="5A6470"/>
-                </a:solidFill>
-                <a:latin typeface="Calibri" pitchFamily="34" charset="0"/>
-                <a:ea typeface="Calibri" pitchFamily="34" charset="-122"/>
-                <a:cs typeface="Calibri" pitchFamily="34" charset="-120"/>
-              </a:rPr>
-              <a:t>Answers: Late, generic handling</a:t>
-            </a:r>
-            <a:endParaRPr lang="en-US" sz="1300" dirty="0"/>
-          </a:p>
-        </p:txBody>
-      </p:sp>
-      <p:sp>
-        <p:nvSpPr>
-          <p:cNvPr id="11" name="Shape 9"/>
-          <p:cNvSpPr/>
-          <p:nvPr/>
-        </p:nvSpPr>
-        <p:spPr>
-          <a:xfrm>
-            <a:off x="548640" y="2487168"/>
-            <a:ext cx="11064240" cy="804672"/>
-          </a:xfrm>
-          <a:prstGeom prst="roundRect">
-            <a:avLst>
-              <a:gd name="adj" fmla="val 11364"/>
-            </a:avLst>
-          </a:prstGeom>
-          <a:solidFill>
-            <a:srgbClr val="EEF2F7"/>
-          </a:solidFill>
-          <a:ln w="12700">
-            <a:solidFill>
-              <a:srgbClr val="EEF2F7"/>
-            </a:solidFill>
-            <a:prstDash val="solid"/>
-          </a:ln>
-        </p:spPr>
-      </p:sp>
-      <p:sp>
-        <p:nvSpPr>
-          <p:cNvPr id="12" name="Shape 10"/>
-          <p:cNvSpPr/>
-          <p:nvPr/>
-        </p:nvSpPr>
-        <p:spPr>
-          <a:xfrm>
-            <a:off x="731520" y="2615184"/>
-            <a:ext cx="548640" cy="548640"/>
-          </a:xfrm>
-          <a:prstGeom prst="ellipse">
-            <a:avLst/>
-          </a:prstGeom>
-          <a:solidFill>
-            <a:srgbClr val="2A9D8F"/>
-          </a:solidFill>
-          <a:ln w="12700">
-            <a:solidFill>
-              <a:srgbClr val="2A9D8F"/>
-            </a:solidFill>
-            <a:prstDash val="solid"/>
-          </a:ln>
-        </p:spPr>
-      </p:sp>
-      <p:sp>
-        <p:nvSpPr>
-          <p:cNvPr id="13" name="Text 11"/>
-          <p:cNvSpPr txBox="1"/>
-          <p:nvPr/>
-        </p:nvSpPr>
-        <p:spPr>
-          <a:xfrm>
-            <a:off x="731520" y="2615184"/>
-            <a:ext cx="548640" cy="548640"/>
-          </a:xfrm>
-          <a:prstGeom prst="rect">
-            <a:avLst/>
-          </a:prstGeom>
-          <a:noFill/>
-          <a:ln/>
-        </p:spPr>
-        <p:txBody>
-          <a:bodyPr wrap="square" lIns="0" tIns="0" rIns="0" bIns="0" rtlCol="0" anchor="ctr"/>
-          <a:lstStyle/>
-          <a:p>
-            <a:pPr algn="ctr" indent="0" marL="0">
-              <a:buNone/>
-            </a:pPr>
-            <a:r>
-              <a:rPr lang="en-US" sz="1800" b="1" dirty="0">
-                <a:solidFill>
-                  <a:srgbClr val="FFFFFF"/>
-                </a:solidFill>
-                <a:latin typeface="Cambria" pitchFamily="34" charset="0"/>
-                <a:ea typeface="Cambria" pitchFamily="34" charset="-122"/>
-                <a:cs typeface="Cambria" pitchFamily="34" charset="-120"/>
-              </a:rPr>
-              <a:t>2</a:t>
-            </a:r>
-            <a:endParaRPr lang="en-US" sz="1800" dirty="0"/>
-          </a:p>
-        </p:txBody>
-      </p:sp>
-      <p:sp>
-        <p:nvSpPr>
-          <p:cNvPr id="14" name="Text 12"/>
-          <p:cNvSpPr txBox="1"/>
-          <p:nvPr/>
-        </p:nvSpPr>
-        <p:spPr>
-          <a:xfrm>
-            <a:off x="1508760" y="2487168"/>
-            <a:ext cx="1280160" cy="804672"/>
-          </a:xfrm>
-          <a:prstGeom prst="rect">
-            <a:avLst/>
-          </a:prstGeom>
-          <a:noFill/>
-          <a:ln/>
-        </p:spPr>
-        <p:txBody>
-          <a:bodyPr wrap="square" lIns="0" tIns="0" rIns="0" bIns="0" rtlCol="0" anchor="ctr"/>
-          <a:lstStyle/>
-          <a:p>
-            <a:pPr indent="0" marL="0">
-              <a:buNone/>
-            </a:pPr>
-            <a:r>
-              <a:rPr lang="en-US" sz="1500" b="1" dirty="0">
-                <a:solidFill>
-                  <a:srgbClr val="1F3A5F"/>
-                </a:solidFill>
-                <a:latin typeface="Cambria" pitchFamily="34" charset="0"/>
-                <a:ea typeface="Cambria" pitchFamily="34" charset="-122"/>
-                <a:cs typeface="Cambria" pitchFamily="34" charset="-120"/>
-              </a:rPr>
-              <a:t>Medium</a:t>
-            </a:r>
-            <a:endParaRPr lang="en-US" sz="1500" dirty="0"/>
-          </a:p>
-        </p:txBody>
-      </p:sp>
-      <p:sp>
-        <p:nvSpPr>
-          <p:cNvPr id="15" name="Text 13"/>
-          <p:cNvSpPr txBox="1"/>
-          <p:nvPr/>
-        </p:nvSpPr>
-        <p:spPr>
-          <a:xfrm>
-            <a:off x="2834640" y="2487168"/>
-            <a:ext cx="5760720" cy="804672"/>
-          </a:xfrm>
-          <a:prstGeom prst="rect">
-            <a:avLst/>
-          </a:prstGeom>
-          <a:noFill/>
-          <a:ln/>
-        </p:spPr>
-        <p:txBody>
-          <a:bodyPr wrap="square" lIns="0" tIns="0" rIns="0" bIns="0" rtlCol="0" anchor="ctr"/>
-          <a:lstStyle/>
-          <a:p>
-            <a:pPr indent="0" marL="0">
-              <a:buNone/>
-            </a:pPr>
-            <a:r>
-              <a:rPr lang="en-US" sz="1400" dirty="0">
-                <a:solidFill>
-                  <a:srgbClr val="1B2733"/>
-                </a:solidFill>
-                <a:latin typeface="Calibri" pitchFamily="34" charset="0"/>
-                <a:ea typeface="Calibri" pitchFamily="34" charset="-122"/>
-                <a:cs typeface="Calibri" pitchFamily="34" charset="-120"/>
-              </a:rPr>
-              <a:t>Japanese neutral review: translate, classify, draft a Japanese reply</a:t>
-            </a:r>
-            <a:endParaRPr lang="en-US" sz="1400" dirty="0"/>
-          </a:p>
-        </p:txBody>
-      </p:sp>
-      <p:sp>
-        <p:nvSpPr>
-          <p:cNvPr id="16" name="Text 14"/>
-          <p:cNvSpPr txBox="1"/>
-          <p:nvPr/>
-        </p:nvSpPr>
-        <p:spPr>
-          <a:xfrm>
-            <a:off x="8686800" y="2487168"/>
-            <a:ext cx="2834640" cy="804672"/>
-          </a:xfrm>
-          <a:prstGeom prst="rect">
-            <a:avLst/>
-          </a:prstGeom>
-          <a:noFill/>
-          <a:ln/>
-        </p:spPr>
-        <p:txBody>
-          <a:bodyPr wrap="square" lIns="0" tIns="0" rIns="0" bIns="0" rtlCol="0" anchor="ctr"/>
-          <a:lstStyle/>
-          <a:p>
-            <a:pPr indent="0" marL="0">
-              <a:buNone/>
-            </a:pPr>
-            <a:r>
-              <a:rPr lang="en-US" sz="1300" i="1" dirty="0">
-                <a:solidFill>
-                  <a:srgbClr val="5A6470"/>
-                </a:solidFill>
-                <a:latin typeface="Calibri" pitchFamily="34" charset="0"/>
-                <a:ea typeface="Calibri" pitchFamily="34" charset="-122"/>
-                <a:cs typeface="Calibri" pitchFamily="34" charset="-120"/>
-              </a:rPr>
-              <a:t>Answers: Language barrier</a:t>
-            </a:r>
-            <a:endParaRPr lang="en-US" sz="1300" dirty="0"/>
-          </a:p>
-        </p:txBody>
-      </p:sp>
-      <p:sp>
-        <p:nvSpPr>
-          <p:cNvPr id="17" name="Shape 15"/>
-          <p:cNvSpPr/>
-          <p:nvPr/>
-        </p:nvSpPr>
-        <p:spPr>
-          <a:xfrm>
-            <a:off x="548640" y="3419856"/>
-            <a:ext cx="11064240" cy="804672"/>
-          </a:xfrm>
-          <a:prstGeom prst="roundRect">
-            <a:avLst>
-              <a:gd name="adj" fmla="val 11364"/>
-            </a:avLst>
-          </a:prstGeom>
-          <a:solidFill>
-            <a:srgbClr val="EEF2F7"/>
-          </a:solidFill>
-          <a:ln w="12700">
-            <a:solidFill>
-              <a:srgbClr val="EEF2F7"/>
-            </a:solidFill>
-            <a:prstDash val="solid"/>
-          </a:ln>
-        </p:spPr>
-      </p:sp>
-      <p:sp>
-        <p:nvSpPr>
-          <p:cNvPr id="18" name="Shape 16"/>
-          <p:cNvSpPr/>
-          <p:nvPr/>
-        </p:nvSpPr>
-        <p:spPr>
-          <a:xfrm>
-            <a:off x="731520" y="3547872"/>
-            <a:ext cx="548640" cy="548640"/>
-          </a:xfrm>
-          <a:prstGeom prst="ellipse">
-            <a:avLst/>
-          </a:prstGeom>
-          <a:solidFill>
-            <a:srgbClr val="E9A23B"/>
-          </a:solidFill>
-          <a:ln w="12700">
-            <a:solidFill>
-              <a:srgbClr val="E9A23B"/>
-            </a:solidFill>
-            <a:prstDash val="solid"/>
-          </a:ln>
-        </p:spPr>
-      </p:sp>
-      <p:sp>
-        <p:nvSpPr>
-          <p:cNvPr id="19" name="Text 17"/>
-          <p:cNvSpPr txBox="1"/>
-          <p:nvPr/>
-        </p:nvSpPr>
-        <p:spPr>
-          <a:xfrm>
-            <a:off x="731520" y="3547872"/>
-            <a:ext cx="548640" cy="548640"/>
-          </a:xfrm>
-          <a:prstGeom prst="rect">
-            <a:avLst/>
-          </a:prstGeom>
-          <a:noFill/>
-          <a:ln/>
-        </p:spPr>
-        <p:txBody>
-          <a:bodyPr wrap="square" lIns="0" tIns="0" rIns="0" bIns="0" rtlCol="0" anchor="ctr"/>
-          <a:lstStyle/>
-          <a:p>
-            <a:pPr algn="ctr" indent="0" marL="0">
-              <a:buNone/>
-            </a:pPr>
-            <a:r>
-              <a:rPr lang="en-US" sz="1800" b="1" dirty="0">
-                <a:solidFill>
-                  <a:srgbClr val="FFFFFF"/>
-                </a:solidFill>
-                <a:latin typeface="Cambria" pitchFamily="34" charset="0"/>
-                <a:ea typeface="Cambria" pitchFamily="34" charset="-122"/>
-                <a:cs typeface="Cambria" pitchFamily="34" charset="-120"/>
-              </a:rPr>
-              <a:t>3</a:t>
-            </a:r>
-            <a:endParaRPr lang="en-US" sz="1800" dirty="0"/>
-          </a:p>
-        </p:txBody>
-      </p:sp>
-      <p:sp>
-        <p:nvSpPr>
-          <p:cNvPr id="20" name="Text 18"/>
-          <p:cNvSpPr txBox="1"/>
-          <p:nvPr/>
-        </p:nvSpPr>
-        <p:spPr>
-          <a:xfrm>
-            <a:off x="1508760" y="3419856"/>
-            <a:ext cx="1280160" cy="804672"/>
-          </a:xfrm>
-          <a:prstGeom prst="rect">
-            <a:avLst/>
-          </a:prstGeom>
-          <a:noFill/>
-          <a:ln/>
-        </p:spPr>
-        <p:txBody>
-          <a:bodyPr wrap="square" lIns="0" tIns="0" rIns="0" bIns="0" rtlCol="0" anchor="ctr"/>
-          <a:lstStyle/>
-          <a:p>
-            <a:pPr indent="0" marL="0">
-              <a:buNone/>
-            </a:pPr>
-            <a:r>
-              <a:rPr lang="en-US" sz="1500" b="1" dirty="0">
-                <a:solidFill>
-                  <a:srgbClr val="1F3A5F"/>
-                </a:solidFill>
-                <a:latin typeface="Cambria" pitchFamily="34" charset="0"/>
-                <a:ea typeface="Cambria" pitchFamily="34" charset="-122"/>
-                <a:cs typeface="Cambria" pitchFamily="34" charset="-120"/>
-              </a:rPr>
-              <a:t>Hard</a:t>
-            </a:r>
-            <a:endParaRPr lang="en-US" sz="1500" dirty="0"/>
-          </a:p>
-        </p:txBody>
-      </p:sp>
-      <p:sp>
-        <p:nvSpPr>
-          <p:cNvPr id="21" name="Text 19"/>
-          <p:cNvSpPr txBox="1"/>
-          <p:nvPr/>
-        </p:nvSpPr>
-        <p:spPr>
-          <a:xfrm>
-            <a:off x="2834640" y="3419856"/>
-            <a:ext cx="5760720" cy="804672"/>
-          </a:xfrm>
-          <a:prstGeom prst="rect">
-            <a:avLst/>
-          </a:prstGeom>
-          <a:noFill/>
-          <a:ln/>
-        </p:spPr>
-        <p:txBody>
-          <a:bodyPr wrap="square" lIns="0" tIns="0" rIns="0" bIns="0" rtlCol="0" anchor="ctr"/>
-          <a:lstStyle/>
-          <a:p>
-            <a:pPr indent="0" marL="0">
-              <a:buNone/>
-            </a:pPr>
-            <a:r>
-              <a:rPr lang="en-US" sz="1400" dirty="0">
-                <a:solidFill>
-                  <a:srgbClr val="1B2733"/>
-                </a:solidFill>
-                <a:latin typeface="Calibri" pitchFamily="34" charset="0"/>
-                <a:ea typeface="Calibri" pitchFamily="34" charset="-122"/>
-                <a:cs typeface="Calibri" pitchFamily="34" charset="-120"/>
-              </a:rPr>
-              <a:t>Run n8n workflow 03 on a six-language batch</a:t>
-            </a:r>
-            <a:endParaRPr lang="en-US" sz="1400" dirty="0"/>
-          </a:p>
-        </p:txBody>
-      </p:sp>
-      <p:sp>
-        <p:nvSpPr>
-          <p:cNvPr id="22" name="Text 20"/>
-          <p:cNvSpPr txBox="1"/>
-          <p:nvPr/>
-        </p:nvSpPr>
-        <p:spPr>
-          <a:xfrm>
-            <a:off x="8686800" y="3419856"/>
-            <a:ext cx="2834640" cy="804672"/>
-          </a:xfrm>
-          <a:prstGeom prst="rect">
-            <a:avLst/>
-          </a:prstGeom>
-          <a:noFill/>
-          <a:ln/>
-        </p:spPr>
-        <p:txBody>
-          <a:bodyPr wrap="square" lIns="0" tIns="0" rIns="0" bIns="0" rtlCol="0" anchor="ctr"/>
-          <a:lstStyle/>
-          <a:p>
-            <a:pPr indent="0" marL="0">
-              <a:buNone/>
-            </a:pPr>
-            <a:r>
-              <a:rPr lang="en-US" sz="1300" i="1" dirty="0">
-                <a:solidFill>
-                  <a:srgbClr val="5A6470"/>
-                </a:solidFill>
-                <a:latin typeface="Calibri" pitchFamily="34" charset="0"/>
-                <a:ea typeface="Calibri" pitchFamily="34" charset="-122"/>
-                <a:cs typeface="Calibri" pitchFamily="34" charset="-120"/>
-              </a:rPr>
-              <a:t>Answers: Manual reading at volume</a:t>
-            </a:r>
-            <a:endParaRPr lang="en-US" sz="1300" dirty="0"/>
-          </a:p>
-        </p:txBody>
-      </p:sp>
-      <p:sp>
-        <p:nvSpPr>
-          <p:cNvPr id="23" name="Shape 21"/>
-          <p:cNvSpPr/>
-          <p:nvPr/>
-        </p:nvSpPr>
-        <p:spPr>
-          <a:xfrm>
-            <a:off x="548640" y="4352544"/>
-            <a:ext cx="11064240" cy="804672"/>
-          </a:xfrm>
-          <a:prstGeom prst="roundRect">
-            <a:avLst>
-              <a:gd name="adj" fmla="val 11364"/>
-            </a:avLst>
-          </a:prstGeom>
-          <a:solidFill>
-            <a:srgbClr val="EEF2F7"/>
-          </a:solidFill>
-          <a:ln w="12700">
-            <a:solidFill>
-              <a:srgbClr val="EEF2F7"/>
-            </a:solidFill>
-            <a:prstDash val="solid"/>
-          </a:ln>
-        </p:spPr>
-      </p:sp>
-      <p:sp>
-        <p:nvSpPr>
-          <p:cNvPr id="24" name="Shape 22"/>
-          <p:cNvSpPr/>
-          <p:nvPr/>
-        </p:nvSpPr>
-        <p:spPr>
-          <a:xfrm>
-            <a:off x="731520" y="4480560"/>
-            <a:ext cx="548640" cy="548640"/>
-          </a:xfrm>
-          <a:prstGeom prst="ellipse">
-            <a:avLst/>
-          </a:prstGeom>
-          <a:solidFill>
-            <a:srgbClr val="E9A23B"/>
-          </a:solidFill>
-          <a:ln w="12700">
-            <a:solidFill>
-              <a:srgbClr val="E9A23B"/>
-            </a:solidFill>
-            <a:prstDash val="solid"/>
-          </a:ln>
-        </p:spPr>
-      </p:sp>
-      <p:sp>
-        <p:nvSpPr>
-          <p:cNvPr id="25" name="Text 23"/>
-          <p:cNvSpPr txBox="1"/>
-          <p:nvPr/>
-        </p:nvSpPr>
-        <p:spPr>
-          <a:xfrm>
-            <a:off x="731520" y="4480560"/>
-            <a:ext cx="548640" cy="548640"/>
-          </a:xfrm>
-          <a:prstGeom prst="rect">
-            <a:avLst/>
-          </a:prstGeom>
-          <a:noFill/>
-          <a:ln/>
-        </p:spPr>
-        <p:txBody>
-          <a:bodyPr wrap="square" lIns="0" tIns="0" rIns="0" bIns="0" rtlCol="0" anchor="ctr"/>
-          <a:lstStyle/>
-          <a:p>
-            <a:pPr algn="ctr" indent="0" marL="0">
-              <a:buNone/>
-            </a:pPr>
-            <a:r>
-              <a:rPr lang="en-US" sz="1800" b="1" dirty="0">
-                <a:solidFill>
-                  <a:srgbClr val="FFFFFF"/>
-                </a:solidFill>
-                <a:latin typeface="Cambria" pitchFamily="34" charset="0"/>
-                <a:ea typeface="Cambria" pitchFamily="34" charset="-122"/>
-                <a:cs typeface="Cambria" pitchFamily="34" charset="-120"/>
-              </a:rPr>
-              <a:t>4</a:t>
-            </a:r>
-            <a:endParaRPr lang="en-US" sz="1800" dirty="0"/>
-          </a:p>
-        </p:txBody>
-      </p:sp>
-      <p:sp>
-        <p:nvSpPr>
-          <p:cNvPr id="26" name="Text 24"/>
-          <p:cNvSpPr txBox="1"/>
-          <p:nvPr/>
-        </p:nvSpPr>
-        <p:spPr>
-          <a:xfrm>
-            <a:off x="1508760" y="4352544"/>
-            <a:ext cx="1280160" cy="804672"/>
-          </a:xfrm>
-          <a:prstGeom prst="rect">
-            <a:avLst/>
-          </a:prstGeom>
-          <a:noFill/>
-          <a:ln/>
-        </p:spPr>
-        <p:txBody>
-          <a:bodyPr wrap="square" lIns="0" tIns="0" rIns="0" bIns="0" rtlCol="0" anchor="ctr"/>
-          <a:lstStyle/>
-          <a:p>
-            <a:pPr indent="0" marL="0">
-              <a:buNone/>
-            </a:pPr>
-            <a:r>
-              <a:rPr lang="en-US" sz="1500" b="1" dirty="0">
-                <a:solidFill>
-                  <a:srgbClr val="1F3A5F"/>
-                </a:solidFill>
-                <a:latin typeface="Cambria" pitchFamily="34" charset="0"/>
-                <a:ea typeface="Cambria" pitchFamily="34" charset="-122"/>
-                <a:cs typeface="Cambria" pitchFamily="34" charset="-120"/>
-              </a:rPr>
-              <a:t>Hard</a:t>
-            </a:r>
-            <a:endParaRPr lang="en-US" sz="1500" dirty="0"/>
-          </a:p>
-        </p:txBody>
-      </p:sp>
-      <p:sp>
-        <p:nvSpPr>
-          <p:cNvPr id="27" name="Text 25"/>
-          <p:cNvSpPr txBox="1"/>
-          <p:nvPr/>
-        </p:nvSpPr>
-        <p:spPr>
-          <a:xfrm>
-            <a:off x="2834640" y="4352544"/>
-            <a:ext cx="5760720" cy="804672"/>
-          </a:xfrm>
-          <a:prstGeom prst="rect">
-            <a:avLst/>
-          </a:prstGeom>
-          <a:noFill/>
-          <a:ln/>
-        </p:spPr>
-        <p:txBody>
-          <a:bodyPr wrap="square" lIns="0" tIns="0" rIns="0" bIns="0" rtlCol="0" anchor="ctr"/>
-          <a:lstStyle/>
-          <a:p>
-            <a:pPr indent="0" marL="0">
-              <a:buNone/>
-            </a:pPr>
-            <a:r>
-              <a:rPr lang="en-US" sz="1400" dirty="0">
-                <a:solidFill>
-                  <a:srgbClr val="1B2733"/>
-                </a:solidFill>
-                <a:latin typeface="Calibri" pitchFamily="34" charset="0"/>
-                <a:ea typeface="Calibri" pitchFamily="34" charset="-122"/>
-                <a:cs typeface="Calibri" pitchFamily="34" charset="-120"/>
-              </a:rPr>
-              <a:t>The mixed 3-star review about the device that restarts itself</a:t>
-            </a:r>
-            <a:endParaRPr lang="en-US" sz="1400" dirty="0"/>
-          </a:p>
-        </p:txBody>
-      </p:sp>
-      <p:sp>
-        <p:nvSpPr>
-          <p:cNvPr id="28" name="Text 26"/>
-          <p:cNvSpPr txBox="1"/>
-          <p:nvPr/>
-        </p:nvSpPr>
-        <p:spPr>
-          <a:xfrm>
-            <a:off x="8686800" y="4352544"/>
-            <a:ext cx="2834640" cy="804672"/>
-          </a:xfrm>
-          <a:prstGeom prst="rect">
-            <a:avLst/>
-          </a:prstGeom>
-          <a:noFill/>
-          <a:ln/>
-        </p:spPr>
-        <p:txBody>
-          <a:bodyPr wrap="square" lIns="0" tIns="0" rIns="0" bIns="0" rtlCol="0" anchor="ctr"/>
-          <a:lstStyle/>
-          <a:p>
-            <a:pPr indent="0" marL="0">
-              <a:buNone/>
-            </a:pPr>
-            <a:r>
-              <a:rPr lang="en-US" sz="1300" i="1" dirty="0">
-                <a:solidFill>
-                  <a:srgbClr val="5A6470"/>
-                </a:solidFill>
-                <a:latin typeface="Calibri" pitchFamily="34" charset="0"/>
-                <a:ea typeface="Calibri" pitchFamily="34" charset="-122"/>
-                <a:cs typeface="Calibri" pitchFamily="34" charset="-120"/>
-              </a:rPr>
-              <a:t>Answers: Stars hide the reason</a:t>
-            </a:r>
-            <a:endParaRPr lang="en-US" sz="1300" dirty="0"/>
-          </a:p>
-        </p:txBody>
-      </p:sp>
-      <p:sp>
-        <p:nvSpPr>
-          <p:cNvPr id="29" name="Shape 27"/>
-          <p:cNvSpPr/>
-          <p:nvPr/>
-        </p:nvSpPr>
-        <p:spPr>
-          <a:xfrm>
-            <a:off x="548640" y="5285232"/>
-            <a:ext cx="11064240" cy="804672"/>
-          </a:xfrm>
-          <a:prstGeom prst="roundRect">
-            <a:avLst>
-              <a:gd name="adj" fmla="val 11364"/>
-            </a:avLst>
-          </a:prstGeom>
-          <a:solidFill>
-            <a:srgbClr val="EEF2F7"/>
-          </a:solidFill>
-          <a:ln w="12700">
-            <a:solidFill>
-              <a:srgbClr val="EEF2F7"/>
-            </a:solidFill>
-            <a:prstDash val="solid"/>
-          </a:ln>
-        </p:spPr>
-      </p:sp>
-      <p:sp>
-        <p:nvSpPr>
-          <p:cNvPr id="30" name="Shape 28"/>
-          <p:cNvSpPr/>
-          <p:nvPr/>
-        </p:nvSpPr>
-        <p:spPr>
-          <a:xfrm>
-            <a:off x="731520" y="5413248"/>
-            <a:ext cx="548640" cy="548640"/>
-          </a:xfrm>
-          <a:prstGeom prst="ellipse">
-            <a:avLst/>
-          </a:prstGeom>
-          <a:solidFill>
-            <a:srgbClr val="C8553D"/>
-          </a:solidFill>
-          <a:ln w="12700">
-            <a:solidFill>
-              <a:srgbClr val="C8553D"/>
-            </a:solidFill>
-            <a:prstDash val="solid"/>
-          </a:ln>
-        </p:spPr>
-      </p:sp>
-      <p:sp>
-        <p:nvSpPr>
-          <p:cNvPr id="31" name="Text 29"/>
-          <p:cNvSpPr txBox="1"/>
-          <p:nvPr/>
-        </p:nvSpPr>
-        <p:spPr>
-          <a:xfrm>
-            <a:off x="731520" y="5413248"/>
-            <a:ext cx="548640" cy="548640"/>
-          </a:xfrm>
-          <a:prstGeom prst="rect">
-            <a:avLst/>
-          </a:prstGeom>
-          <a:noFill/>
-          <a:ln/>
-        </p:spPr>
-        <p:txBody>
-          <a:bodyPr wrap="square" lIns="0" tIns="0" rIns="0" bIns="0" rtlCol="0" anchor="ctr"/>
-          <a:lstStyle/>
-          <a:p>
-            <a:pPr algn="ctr" indent="0" marL="0">
-              <a:buNone/>
-            </a:pPr>
-            <a:r>
-              <a:rPr lang="en-US" sz="1800" b="1" dirty="0">
-                <a:solidFill>
-                  <a:srgbClr val="FFFFFF"/>
-                </a:solidFill>
-                <a:latin typeface="Cambria" pitchFamily="34" charset="0"/>
-                <a:ea typeface="Cambria" pitchFamily="34" charset="-122"/>
-                <a:cs typeface="Cambria" pitchFamily="34" charset="-120"/>
-              </a:rPr>
-              <a:t>5</a:t>
-            </a:r>
-            <a:endParaRPr lang="en-US" sz="1800" dirty="0"/>
-          </a:p>
-        </p:txBody>
-      </p:sp>
-      <p:sp>
-        <p:nvSpPr>
-          <p:cNvPr id="32" name="Text 30"/>
-          <p:cNvSpPr txBox="1"/>
-          <p:nvPr/>
-        </p:nvSpPr>
-        <p:spPr>
-          <a:xfrm>
-            <a:off x="1508760" y="5285232"/>
-            <a:ext cx="1280160" cy="804672"/>
-          </a:xfrm>
-          <a:prstGeom prst="rect">
-            <a:avLst/>
-          </a:prstGeom>
-          <a:noFill/>
-          <a:ln/>
-        </p:spPr>
-        <p:txBody>
-          <a:bodyPr wrap="square" lIns="0" tIns="0" rIns="0" bIns="0" rtlCol="0" anchor="ctr"/>
-          <a:lstStyle/>
-          <a:p>
-            <a:pPr indent="0" marL="0">
-              <a:buNone/>
-            </a:pPr>
-            <a:r>
-              <a:rPr lang="en-US" sz="1500" b="1" dirty="0">
-                <a:solidFill>
-                  <a:srgbClr val="1F3A5F"/>
-                </a:solidFill>
-                <a:latin typeface="Cambria" pitchFamily="34" charset="0"/>
-                <a:ea typeface="Cambria" pitchFamily="34" charset="-122"/>
-                <a:cs typeface="Cambria" pitchFamily="34" charset="-120"/>
-              </a:rPr>
-              <a:t>Hardest</a:t>
-            </a:r>
-            <a:endParaRPr lang="en-US" sz="1500" dirty="0"/>
-          </a:p>
-        </p:txBody>
-      </p:sp>
-      <p:sp>
-        <p:nvSpPr>
-          <p:cNvPr id="33" name="Text 31"/>
-          <p:cNvSpPr txBox="1"/>
-          <p:nvPr/>
-        </p:nvSpPr>
-        <p:spPr>
-          <a:xfrm>
-            <a:off x="2834640" y="5285232"/>
-            <a:ext cx="5760720" cy="804672"/>
-          </a:xfrm>
-          <a:prstGeom prst="rect">
-            <a:avLst/>
-          </a:prstGeom>
-          <a:noFill/>
-          <a:ln/>
-        </p:spPr>
-        <p:txBody>
-          <a:bodyPr wrap="square" lIns="0" tIns="0" rIns="0" bIns="0" rtlCol="0" anchor="ctr"/>
-          <a:lstStyle/>
-          <a:p>
-            <a:pPr indent="0" marL="0">
-              <a:buNone/>
-            </a:pPr>
-            <a:r>
-              <a:rPr lang="en-US" sz="1400" dirty="0">
-                <a:solidFill>
-                  <a:srgbClr val="1B2733"/>
-                </a:solidFill>
-                <a:latin typeface="Calibri" pitchFamily="34" charset="0"/>
-                <a:ea typeface="Calibri" pitchFamily="34" charset="-122"/>
-                <a:cs typeface="Calibri" pitchFamily="34" charset="-120"/>
-              </a:rPr>
-              <a:t>Run workflow 04: spike found, Slack message arrives</a:t>
-            </a:r>
-            <a:endParaRPr lang="en-US" sz="1400" dirty="0"/>
-          </a:p>
-        </p:txBody>
-      </p:sp>
-      <p:sp>
-        <p:nvSpPr>
-          <p:cNvPr id="34" name="Text 32"/>
-          <p:cNvSpPr txBox="1"/>
-          <p:nvPr/>
-        </p:nvSpPr>
-        <p:spPr>
-          <a:xfrm>
-            <a:off x="8686800" y="5285232"/>
-            <a:ext cx="2834640" cy="804672"/>
-          </a:xfrm>
-          <a:prstGeom prst="rect">
-            <a:avLst/>
-          </a:prstGeom>
-          <a:noFill/>
-          <a:ln/>
-        </p:spPr>
-        <p:txBody>
-          <a:bodyPr wrap="square" lIns="0" tIns="0" rIns="0" bIns="0" rtlCol="0" anchor="ctr"/>
-          <a:lstStyle/>
-          <a:p>
-            <a:pPr indent="0" marL="0">
-              <a:buNone/>
-            </a:pPr>
-            <a:r>
-              <a:rPr lang="en-US" sz="1300" i="1" dirty="0">
-                <a:solidFill>
-                  <a:srgbClr val="5A6470"/>
-                </a:solidFill>
-                <a:latin typeface="Calibri" pitchFamily="34" charset="0"/>
-                <a:ea typeface="Calibri" pitchFamily="34" charset="-122"/>
-                <a:cs typeface="Calibri" pitchFamily="34" charset="-120"/>
-              </a:rPr>
-              <a:t>Answers: Spikes found late</a:t>
-            </a:r>
-            <a:endParaRPr lang="en-US" sz="1300" dirty="0"/>
-          </a:p>
-        </p:txBody>
-      </p:sp>
-      <p:sp>
-        <p:nvSpPr>
-          <p:cNvPr id="25" name="Slide Number Placeholder 0"/>
-          <p:cNvSpPr>
-            <a:spLocks noGrp="1"/>
-          </p:cNvSpPr>
-          <p:nvPr>
-            <p:ph type="sldNum" sz="quarter" idx="4294967295"/>
-          </p:nvPr>
-        </p:nvSpPr>
-        <p:spPr>
-          <a:xfrm>
-            <a:off x="11155680" y="6446520"/>
-            <a:ext cx="548640" cy="274320"/>
-          </a:xfrm>
-          <a:prstGeom prst="rect">
-            <a:avLst/>
-          </a:prstGeom>
-          <a:extLst>
-            <a:ext uri="{C572A759-6A51-4108-AA02-DFA0A04FC94B}">
-              <ma14:wrappingTextBoxFlag xmlns:ma14="http://schemas.microsoft.com/office/mac/drawingml/2011/main" val="0"/>
-            </a:ext>
-          </a:extLst>
-        </p:spPr>
-        <p:txBody>
-          <a:bodyPr/>
-          <a:lstStyle>
-            <a:lvl1pPr>
-              <a:defRPr sz="1000">
-                <a:solidFill>
-                  <a:srgbClr val="5A6470"/>
-                </a:solidFill>
-                <a:latin typeface="Calibri"/>
-                <a:ea typeface="Calibri"/>
-                <a:cs typeface="Calibri"/>
-              </a:defRPr>
-            </a:lvl1pPr>
-          </a:lstStyle>
-          <a:p>
-            <a:pPr algn="r"/>
-            <a:fld id="{F7021451-1387-4CA6-816F-3879F97B5CBC}" type="slidenum">
-              <a:rPr b="0" lang="en-US"/>
               <a:t>17</a:t>
             </a:fld>
             <a:endParaRPr lang="en-US"/>
@@ -14058,7 +13233,7 @@
                 <a:ea typeface="Calibri" pitchFamily="34" charset="-122"/>
                 <a:cs typeface="Calibri" pitchFamily="34" charset="-120"/>
               </a:rPr>
-              <a:t>LIMITATIONS AND FUTURE SCOPE</a:t>
+              <a:t>LIVE DEMO</a:t>
             </a:r>
             <a:endParaRPr lang="en-US" sz="1200" dirty="0"/>
           </a:p>
@@ -14097,7 +13272,7 @@
                 <a:ea typeface="Cambria" pitchFamily="34" charset="-122"/>
                 <a:cs typeface="Cambria" pitchFamily="34" charset="-120"/>
               </a:rPr>
-              <a:t>Limitations and where we go next</a:t>
+              <a:t>Demo plan: five tasks, from easy to hardest</a:t>
             </a:r>
             <a:endParaRPr lang="en-US" sz="3000" dirty="0"/>
           </a:p>
@@ -14151,246 +13326,11 @@
         <p:spPr>
           <a:xfrm>
             <a:off x="548640" y="1554480"/>
-            <a:ext cx="5394960" cy="4480560"/>
+            <a:ext cx="11064240" cy="804672"/>
           </a:xfrm>
           <a:prstGeom prst="roundRect">
             <a:avLst>
-              <a:gd name="adj" fmla="val 2041"/>
-            </a:avLst>
-          </a:prstGeom>
-          <a:solidFill>
-            <a:srgbClr val="FFF4DC"/>
-          </a:solidFill>
-          <a:ln w="12700">
-            <a:solidFill>
-              <a:srgbClr val="FFF4DC"/>
-            </a:solidFill>
-            <a:prstDash val="solid"/>
-          </a:ln>
-        </p:spPr>
-      </p:sp>
-      <p:sp>
-        <p:nvSpPr>
-          <p:cNvPr id="6" name="Text 4"/>
-          <p:cNvSpPr txBox="1"/>
-          <p:nvPr/>
-        </p:nvSpPr>
-        <p:spPr>
-          <a:xfrm>
-            <a:off x="731520" y="1691640"/>
-            <a:ext cx="5029200" cy="365760"/>
-          </a:xfrm>
-          <a:prstGeom prst="rect">
-            <a:avLst/>
-          </a:prstGeom>
-          <a:noFill/>
-          <a:ln/>
-        </p:spPr>
-        <p:txBody>
-          <a:bodyPr wrap="square" lIns="0" tIns="0" rIns="0" bIns="0" rtlCol="0" anchor="t"/>
-          <a:lstStyle/>
-          <a:p>
-            <a:pPr indent="0" marL="0">
-              <a:buNone/>
-            </a:pPr>
-            <a:r>
-              <a:rPr lang="en-US" sz="1600" b="1" dirty="0">
-                <a:solidFill>
-                  <a:srgbClr val="1F3A5F"/>
-                </a:solidFill>
-                <a:latin typeface="Cambria" pitchFamily="34" charset="0"/>
-                <a:ea typeface="Cambria" pitchFamily="34" charset="-122"/>
-                <a:cs typeface="Cambria" pitchFamily="34" charset="-120"/>
-              </a:rPr>
-              <a:t>Limitations</a:t>
-            </a:r>
-            <a:endParaRPr lang="en-US" sz="1600" dirty="0"/>
-          </a:p>
-        </p:txBody>
-      </p:sp>
-      <p:sp>
-        <p:nvSpPr>
-          <p:cNvPr id="7" name="Text 5"/>
-          <p:cNvSpPr txBox="1"/>
-          <p:nvPr/>
-        </p:nvSpPr>
-        <p:spPr>
-          <a:xfrm>
-            <a:off x="731520" y="2103120"/>
-            <a:ext cx="5029200" cy="3794760"/>
-          </a:xfrm>
-          <a:prstGeom prst="rect">
-            <a:avLst/>
-          </a:prstGeom>
-          <a:noFill/>
-          <a:ln/>
-        </p:spPr>
-        <p:txBody>
-          <a:bodyPr wrap="square" lIns="0" tIns="0" rIns="0" bIns="0" rtlCol="0" anchor="t"/>
-          <a:lstStyle/>
-          <a:p>
-            <a:pPr marL="342900" indent="-342900">
-              <a:spcAft>
-                <a:spcPts val="800"/>
-              </a:spcAft>
-              <a:buSzPct val="100000"/>
-              <a:buChar char="•"/>
-            </a:pPr>
-            <a:r>
-              <a:rPr lang="en-US" sz="1700" dirty="0">
-                <a:solidFill>
-                  <a:srgbClr val="1B2733"/>
-                </a:solidFill>
-                <a:latin typeface="Calibri" pitchFamily="34" charset="0"/>
-                <a:ea typeface="Calibri" pitchFamily="34" charset="-122"/>
-                <a:cs typeface="Calibri" pitchFamily="34" charset="-120"/>
-              </a:rPr>
-              <a:t>Simulated dates; threshold tuned on the same simulation</a:t>
-            </a:r>
-            <a:endParaRPr lang="en-US" sz="1300" dirty="0"/>
-          </a:p>
-          <a:p>
-            <a:pPr marL="342900" indent="-342900">
-              <a:spcAft>
-                <a:spcPts val="800"/>
-              </a:spcAft>
-              <a:buSzPct val="100000"/>
-              <a:buChar char="•"/>
-            </a:pPr>
-            <a:r>
-              <a:rPr lang="en-US" sz="1700" dirty="0">
-                <a:solidFill>
-                  <a:srgbClr val="1B2733"/>
-                </a:solidFill>
-                <a:latin typeface="Calibri" pitchFamily="34" charset="0"/>
-                <a:ea typeface="Calibri" pitchFamily="34" charset="-122"/>
-                <a:cs typeface="Calibri" pitchFamily="34" charset="-120"/>
-              </a:rPr>
-              <a:t>Three-way sentiment 78.1%, neutral class weak</a:t>
-            </a:r>
-            <a:endParaRPr lang="en-US" sz="1300" dirty="0"/>
-          </a:p>
-          <a:p>
-            <a:pPr marL="342900" indent="-342900">
-              <a:spcAft>
-                <a:spcPts val="800"/>
-              </a:spcAft>
-              <a:buSzPct val="100000"/>
-              <a:buChar char="•"/>
-            </a:pPr>
-            <a:r>
-              <a:rPr lang="en-US" sz="1700" dirty="0">
-                <a:solidFill>
-                  <a:srgbClr val="1B2733"/>
-                </a:solidFill>
-                <a:latin typeface="Calibri" pitchFamily="34" charset="0"/>
-                <a:ea typeface="Calibri" pitchFamily="34" charset="-122"/>
-                <a:cs typeface="Calibri" pitchFamily="34" charset="-120"/>
-              </a:rPr>
-              <a:t>No human test of reply quality</a:t>
-            </a:r>
-            <a:endParaRPr lang="en-US" sz="1300" dirty="0"/>
-          </a:p>
-          <a:p>
-            <a:pPr marL="342900" indent="-342900">
-              <a:spcAft>
-                <a:spcPts val="800"/>
-              </a:spcAft>
-              <a:buSzPct val="100000"/>
-              <a:buChar char="•"/>
-            </a:pPr>
-            <a:r>
-              <a:rPr lang="en-US" sz="1700" dirty="0">
-                <a:solidFill>
-                  <a:srgbClr val="1B2733"/>
-                </a:solidFill>
-                <a:latin typeface="Calibri" pitchFamily="34" charset="0"/>
-                <a:ea typeface="Calibri" pitchFamily="34" charset="-122"/>
-                <a:cs typeface="Calibri" pitchFamily="34" charset="-120"/>
-              </a:rPr>
-              <a:t>Neutral and Japanese replies are weakest</a:t>
-            </a:r>
-            <a:endParaRPr lang="en-US" sz="1300" dirty="0"/>
-          </a:p>
-          <a:p>
-            <a:pPr marL="342900" indent="-342900">
-              <a:spcAft>
-                <a:spcPts val="800"/>
-              </a:spcAft>
-              <a:buSzPct val="100000"/>
-              <a:buChar char="•"/>
-            </a:pPr>
-            <a:r>
-              <a:rPr lang="en-US" sz="1700" dirty="0">
-                <a:solidFill>
-                  <a:srgbClr val="1B2733"/>
-                </a:solidFill>
-                <a:latin typeface="Calibri" pitchFamily="34" charset="0"/>
-                <a:ea typeface="Calibri" pitchFamily="34" charset="-122"/>
-                <a:cs typeface="Calibri" pitchFamily="34" charset="-120"/>
-              </a:rPr>
-              <a:t>Issue categories in n8n agree 43% with k-means</a:t>
-            </a:r>
-            <a:endParaRPr lang="en-US" sz="1300" dirty="0"/>
-          </a:p>
-          <a:p>
-            <a:pPr marL="342900" indent="-342900">
-              <a:spcAft>
-                <a:spcPts val="800"/>
-              </a:spcAft>
-              <a:buSzPct val="100000"/>
-              <a:buChar char="•"/>
-            </a:pPr>
-            <a:r>
-              <a:rPr lang="en-US" sz="1700" dirty="0">
-                <a:solidFill>
-                  <a:srgbClr val="1B2733"/>
-                </a:solidFill>
-                <a:latin typeface="Calibri" pitchFamily="34" charset="0"/>
-                <a:ea typeface="Calibri" pitchFamily="34" charset="-122"/>
-                <a:cs typeface="Calibri" pitchFamily="34" charset="-120"/>
-              </a:rPr>
-              <a:t>Small test sets; results move by a few points</a:t>
-            </a:r>
-            <a:endParaRPr lang="en-US" sz="1300" dirty="0"/>
-          </a:p>
-          <a:p>
-            <a:pPr marL="342900" indent="-342900">
-              <a:spcAft>
-                <a:spcPts val="800"/>
-              </a:spcAft>
-              <a:buSzPct val="100000"/>
-              <a:buChar char="•"/>
-            </a:pPr>
-            <a:r>
-              <a:rPr lang="en-US" sz="1700" dirty="0">
-                <a:solidFill>
-                  <a:srgbClr val="1B2733"/>
-                </a:solidFill>
-                <a:latin typeface="Calibri" pitchFamily="34" charset="0"/>
-                <a:ea typeface="Calibri" pitchFamily="34" charset="-122"/>
-                <a:cs typeface="Calibri" pitchFamily="34" charset="-120"/>
-              </a:rPr>
-              <a:t>Sheet updated by paste; n8n runs start by hand</a:t>
-            </a:r>
-            <a:endParaRPr lang="en-US" sz="1300" dirty="0"/>
-          </a:p>
-        </p:txBody>
-      </p:sp>
-      <p:sp>
-        <p:nvSpPr>
-          <p:cNvPr id="8" name="Shape 6"/>
-          <p:cNvSpPr/>
-          <p:nvPr/>
-        </p:nvSpPr>
-        <p:spPr>
-          <a:xfrm>
-            <a:off x="6217920" y="1554480"/>
-            <a:ext cx="5394960" cy="4480560"/>
-          </a:xfrm>
-          <a:prstGeom prst="roundRect">
-            <a:avLst>
-              <a:gd name="adj" fmla="val 2041"/>
+              <a:gd name="adj" fmla="val 11364"/>
             </a:avLst>
           </a:prstGeom>
           <a:solidFill>
@@ -14406,14 +13346,39 @@
       </p:sp>
       <p:sp>
         <p:nvSpPr>
-          <p:cNvPr id="9" name="Text 7"/>
+          <p:cNvPr id="6" name="Shape 4"/>
+          <p:cNvSpPr/>
+          <p:nvPr/>
+        </p:nvSpPr>
+        <p:spPr>
+          <a:xfrm>
+            <a:off x="731520" y="1682496"/>
+            <a:ext cx="548640" cy="548640"/>
+          </a:xfrm>
+          <a:prstGeom prst="ellipse">
+            <a:avLst/>
+          </a:prstGeom>
+          <a:solidFill>
+            <a:srgbClr val="2A9D8F"/>
+          </a:solidFill>
+          <a:ln w="12700">
+            <a:solidFill>
+              <a:srgbClr val="2A9D8F"/>
+            </a:solidFill>
+            <a:prstDash val="solid"/>
+          </a:ln>
+        </p:spPr>
+      </p:sp>
+      <p:sp>
+        <p:nvSpPr>
+          <p:cNvPr id="7" name="Text 5"/>
           <p:cNvSpPr txBox="1"/>
           <p:nvPr/>
         </p:nvSpPr>
         <p:spPr>
           <a:xfrm>
-            <a:off x="6400800" y="1691640"/>
-            <a:ext cx="5029200" cy="365760"/>
+            <a:off x="731520" y="1682496"/>
+            <a:ext cx="548640" cy="548640"/>
           </a:xfrm>
           <a:prstGeom prst="rect">
             <a:avLst/>
@@ -14422,37 +13387,37 @@
           <a:ln/>
         </p:spPr>
         <p:txBody>
-          <a:bodyPr wrap="square" lIns="0" tIns="0" rIns="0" bIns="0" rtlCol="0" anchor="t"/>
-          <a:lstStyle/>
-          <a:p>
-            <a:pPr indent="0" marL="0">
+          <a:bodyPr wrap="square" lIns="0" tIns="0" rIns="0" bIns="0" rtlCol="0" anchor="ctr"/>
+          <a:lstStyle/>
+          <a:p>
+            <a:pPr algn="ctr" indent="0" marL="0">
               <a:buNone/>
             </a:pPr>
             <a:r>
-              <a:rPr lang="en-US" sz="1600" b="1" dirty="0">
-                <a:solidFill>
-                  <a:srgbClr val="1F3A5F"/>
+              <a:rPr lang="en-US" sz="1800" b="1" dirty="0">
+                <a:solidFill>
+                  <a:srgbClr val="FFFFFF"/>
                 </a:solidFill>
                 <a:latin typeface="Cambria" pitchFamily="34" charset="0"/>
                 <a:ea typeface="Cambria" pitchFamily="34" charset="-122"/>
                 <a:cs typeface="Cambria" pitchFamily="34" charset="-120"/>
               </a:rPr>
-              <a:t>Future scope and scaling</a:t>
-            </a:r>
-            <a:endParaRPr lang="en-US" sz="1600" dirty="0"/>
-          </a:p>
-        </p:txBody>
-      </p:sp>
-      <p:sp>
-        <p:nvSpPr>
-          <p:cNvPr id="10" name="Text 8"/>
+              <a:t>1</a:t>
+            </a:r>
+            <a:endParaRPr lang="en-US" sz="1800" dirty="0"/>
+          </a:p>
+        </p:txBody>
+      </p:sp>
+      <p:sp>
+        <p:nvSpPr>
+          <p:cNvPr id="8" name="Text 6"/>
           <p:cNvSpPr txBox="1"/>
           <p:nvPr/>
         </p:nvSpPr>
         <p:spPr>
           <a:xfrm>
-            <a:off x="6400800" y="2103120"/>
-            <a:ext cx="5029200" cy="3794760"/>
+            <a:off x="1508760" y="1554480"/>
+            <a:ext cx="1280160" cy="804672"/>
           </a:xfrm>
           <a:prstGeom prst="rect">
             <a:avLst/>
@@ -14461,18 +13426,53 @@
           <a:ln/>
         </p:spPr>
         <p:txBody>
-          <a:bodyPr wrap="square" lIns="0" tIns="0" rIns="0" bIns="0" rtlCol="0" anchor="t"/>
-          <a:lstStyle/>
-          <a:p>
-            <a:pPr marL="342900" indent="-342900">
-              <a:spcAft>
-                <a:spcPts val="800"/>
-              </a:spcAft>
-              <a:buSzPct val="100000"/>
-              <a:buChar char="•"/>
-            </a:pPr>
-            <a:r>
-              <a:rPr lang="en-US" sz="1700" dirty="0">
+          <a:bodyPr wrap="square" lIns="0" tIns="0" rIns="0" bIns="0" rtlCol="0" anchor="ctr"/>
+          <a:lstStyle/>
+          <a:p>
+            <a:pPr indent="0" marL="0">
+              <a:buNone/>
+            </a:pPr>
+            <a:r>
+              <a:rPr lang="en-US" sz="1500" b="1" dirty="0">
+                <a:solidFill>
+                  <a:srgbClr val="1F3A5F"/>
+                </a:solidFill>
+                <a:latin typeface="Cambria" pitchFamily="34" charset="0"/>
+                <a:ea typeface="Cambria" pitchFamily="34" charset="-122"/>
+                <a:cs typeface="Cambria" pitchFamily="34" charset="-120"/>
+              </a:rPr>
+              <a:t>Easy</a:t>
+            </a:r>
+            <a:endParaRPr lang="en-US" sz="1500" dirty="0"/>
+          </a:p>
+        </p:txBody>
+      </p:sp>
+      <p:sp>
+        <p:nvSpPr>
+          <p:cNvPr id="9" name="Text 7"/>
+          <p:cNvSpPr txBox="1"/>
+          <p:nvPr/>
+        </p:nvSpPr>
+        <p:spPr>
+          <a:xfrm>
+            <a:off x="2834640" y="1554480"/>
+            <a:ext cx="5760720" cy="804672"/>
+          </a:xfrm>
+          <a:prstGeom prst="rect">
+            <a:avLst/>
+          </a:prstGeom>
+          <a:noFill/>
+          <a:ln/>
+        </p:spPr>
+        <p:txBody>
+          <a:bodyPr wrap="square" lIns="0" tIns="0" rIns="0" bIns="0" rtlCol="0" anchor="ctr"/>
+          <a:lstStyle/>
+          <a:p>
+            <a:pPr indent="0" marL="0">
+              <a:buNone/>
+            </a:pPr>
+            <a:r>
+              <a:rPr lang="en-US" sz="1400" dirty="0">
                 <a:solidFill>
                   <a:srgbClr val="1B2733"/>
                 </a:solidFill>
@@ -14480,41 +13480,207 @@
                 <a:ea typeface="Calibri" pitchFamily="34" charset="-122"/>
                 <a:cs typeface="Calibri" pitchFamily="34" charset="-120"/>
               </a:rPr>
-              <a:t>Connect a real dated review feed and retune spikes</a:t>
-            </a:r>
-            <a:endParaRPr lang="en-US" sz="1300" dirty="0"/>
-          </a:p>
-          <a:p>
-            <a:pPr marL="342900" indent="-342900">
-              <a:spcAft>
-                <a:spcPts val="800"/>
-              </a:spcAft>
-              <a:buSzPct val="100000"/>
-              <a:buChar char="•"/>
-            </a:pPr>
-            <a:r>
-              <a:rPr lang="en-US" sz="1700" dirty="0">
-                <a:solidFill>
-                  <a:srgbClr val="1B2733"/>
+              <a:t>Classify one review: “arrived late and the box was crushed”</a:t>
+            </a:r>
+            <a:endParaRPr lang="en-US" sz="1400" dirty="0"/>
+          </a:p>
+        </p:txBody>
+      </p:sp>
+      <p:sp>
+        <p:nvSpPr>
+          <p:cNvPr id="10" name="Text 8"/>
+          <p:cNvSpPr txBox="1"/>
+          <p:nvPr/>
+        </p:nvSpPr>
+        <p:spPr>
+          <a:xfrm>
+            <a:off x="8686800" y="1554480"/>
+            <a:ext cx="2834640" cy="804672"/>
+          </a:xfrm>
+          <a:prstGeom prst="rect">
+            <a:avLst/>
+          </a:prstGeom>
+          <a:noFill/>
+          <a:ln/>
+        </p:spPr>
+        <p:txBody>
+          <a:bodyPr wrap="square" lIns="0" tIns="0" rIns="0" bIns="0" rtlCol="0" anchor="ctr"/>
+          <a:lstStyle/>
+          <a:p>
+            <a:pPr indent="0" marL="0">
+              <a:buNone/>
+            </a:pPr>
+            <a:r>
+              <a:rPr lang="en-US" sz="1300" i="1" dirty="0">
+                <a:solidFill>
+                  <a:srgbClr val="5A6470"/>
                 </a:solidFill>
                 <a:latin typeface="Calibri" pitchFamily="34" charset="0"/>
                 <a:ea typeface="Calibri" pitchFamily="34" charset="-122"/>
                 <a:cs typeface="Calibri" pitchFamily="34" charset="-120"/>
               </a:rPr>
-              <a:t>Human evaluation with support staff</a:t>
+              <a:t>Answers: Late, generic handling</a:t>
             </a:r>
             <a:endParaRPr lang="en-US" sz="1300" dirty="0"/>
           </a:p>
-          <a:p>
-            <a:pPr marL="342900" indent="-342900">
-              <a:spcAft>
-                <a:spcPts val="800"/>
-              </a:spcAft>
-              <a:buSzPct val="100000"/>
-              <a:buChar char="•"/>
-            </a:pPr>
-            <a:r>
-              <a:rPr lang="en-US" sz="1700" dirty="0">
+        </p:txBody>
+      </p:sp>
+      <p:sp>
+        <p:nvSpPr>
+          <p:cNvPr id="11" name="Shape 9"/>
+          <p:cNvSpPr/>
+          <p:nvPr/>
+        </p:nvSpPr>
+        <p:spPr>
+          <a:xfrm>
+            <a:off x="548640" y="2487168"/>
+            <a:ext cx="11064240" cy="804672"/>
+          </a:xfrm>
+          <a:prstGeom prst="roundRect">
+            <a:avLst>
+              <a:gd name="adj" fmla="val 11364"/>
+            </a:avLst>
+          </a:prstGeom>
+          <a:solidFill>
+            <a:srgbClr val="EEF2F7"/>
+          </a:solidFill>
+          <a:ln w="12700">
+            <a:solidFill>
+              <a:srgbClr val="EEF2F7"/>
+            </a:solidFill>
+            <a:prstDash val="solid"/>
+          </a:ln>
+        </p:spPr>
+      </p:sp>
+      <p:sp>
+        <p:nvSpPr>
+          <p:cNvPr id="12" name="Shape 10"/>
+          <p:cNvSpPr/>
+          <p:nvPr/>
+        </p:nvSpPr>
+        <p:spPr>
+          <a:xfrm>
+            <a:off x="731520" y="2615184"/>
+            <a:ext cx="548640" cy="548640"/>
+          </a:xfrm>
+          <a:prstGeom prst="ellipse">
+            <a:avLst/>
+          </a:prstGeom>
+          <a:solidFill>
+            <a:srgbClr val="2A9D8F"/>
+          </a:solidFill>
+          <a:ln w="12700">
+            <a:solidFill>
+              <a:srgbClr val="2A9D8F"/>
+            </a:solidFill>
+            <a:prstDash val="solid"/>
+          </a:ln>
+        </p:spPr>
+      </p:sp>
+      <p:sp>
+        <p:nvSpPr>
+          <p:cNvPr id="13" name="Text 11"/>
+          <p:cNvSpPr txBox="1"/>
+          <p:nvPr/>
+        </p:nvSpPr>
+        <p:spPr>
+          <a:xfrm>
+            <a:off x="731520" y="2615184"/>
+            <a:ext cx="548640" cy="548640"/>
+          </a:xfrm>
+          <a:prstGeom prst="rect">
+            <a:avLst/>
+          </a:prstGeom>
+          <a:noFill/>
+          <a:ln/>
+        </p:spPr>
+        <p:txBody>
+          <a:bodyPr wrap="square" lIns="0" tIns="0" rIns="0" bIns="0" rtlCol="0" anchor="ctr"/>
+          <a:lstStyle/>
+          <a:p>
+            <a:pPr algn="ctr" indent="0" marL="0">
+              <a:buNone/>
+            </a:pPr>
+            <a:r>
+              <a:rPr lang="en-US" sz="1800" b="1" dirty="0">
+                <a:solidFill>
+                  <a:srgbClr val="FFFFFF"/>
+                </a:solidFill>
+                <a:latin typeface="Cambria" pitchFamily="34" charset="0"/>
+                <a:ea typeface="Cambria" pitchFamily="34" charset="-122"/>
+                <a:cs typeface="Cambria" pitchFamily="34" charset="-120"/>
+              </a:rPr>
+              <a:t>2</a:t>
+            </a:r>
+            <a:endParaRPr lang="en-US" sz="1800" dirty="0"/>
+          </a:p>
+        </p:txBody>
+      </p:sp>
+      <p:sp>
+        <p:nvSpPr>
+          <p:cNvPr id="14" name="Text 12"/>
+          <p:cNvSpPr txBox="1"/>
+          <p:nvPr/>
+        </p:nvSpPr>
+        <p:spPr>
+          <a:xfrm>
+            <a:off x="1508760" y="2487168"/>
+            <a:ext cx="1280160" cy="804672"/>
+          </a:xfrm>
+          <a:prstGeom prst="rect">
+            <a:avLst/>
+          </a:prstGeom>
+          <a:noFill/>
+          <a:ln/>
+        </p:spPr>
+        <p:txBody>
+          <a:bodyPr wrap="square" lIns="0" tIns="0" rIns="0" bIns="0" rtlCol="0" anchor="ctr"/>
+          <a:lstStyle/>
+          <a:p>
+            <a:pPr indent="0" marL="0">
+              <a:buNone/>
+            </a:pPr>
+            <a:r>
+              <a:rPr lang="en-US" sz="1500" b="1" dirty="0">
+                <a:solidFill>
+                  <a:srgbClr val="1F3A5F"/>
+                </a:solidFill>
+                <a:latin typeface="Cambria" pitchFamily="34" charset="0"/>
+                <a:ea typeface="Cambria" pitchFamily="34" charset="-122"/>
+                <a:cs typeface="Cambria" pitchFamily="34" charset="-120"/>
+              </a:rPr>
+              <a:t>Medium</a:t>
+            </a:r>
+            <a:endParaRPr lang="en-US" sz="1500" dirty="0"/>
+          </a:p>
+        </p:txBody>
+      </p:sp>
+      <p:sp>
+        <p:nvSpPr>
+          <p:cNvPr id="15" name="Text 13"/>
+          <p:cNvSpPr txBox="1"/>
+          <p:nvPr/>
+        </p:nvSpPr>
+        <p:spPr>
+          <a:xfrm>
+            <a:off x="2834640" y="2487168"/>
+            <a:ext cx="5760720" cy="804672"/>
+          </a:xfrm>
+          <a:prstGeom prst="rect">
+            <a:avLst/>
+          </a:prstGeom>
+          <a:noFill/>
+          <a:ln/>
+        </p:spPr>
+        <p:txBody>
+          <a:bodyPr wrap="square" lIns="0" tIns="0" rIns="0" bIns="0" rtlCol="0" anchor="ctr"/>
+          <a:lstStyle/>
+          <a:p>
+            <a:pPr indent="0" marL="0">
+              <a:buNone/>
+            </a:pPr>
+            <a:r>
+              <a:rPr lang="en-US" sz="1400" dirty="0">
                 <a:solidFill>
                   <a:srgbClr val="1B2733"/>
                 </a:solidFill>
@@ -14522,41 +13688,207 @@
                 <a:ea typeface="Calibri" pitchFamily="34" charset="-122"/>
                 <a:cs typeface="Calibri" pitchFamily="34" charset="-120"/>
               </a:rPr>
-              <a:t>Add a separate 'mixed' flag for neutral reviews</a:t>
-            </a:r>
-            <a:endParaRPr lang="en-US" sz="1300" dirty="0"/>
-          </a:p>
-          <a:p>
-            <a:pPr marL="342900" indent="-342900">
-              <a:spcAft>
-                <a:spcPts val="800"/>
-              </a:spcAft>
-              <a:buSzPct val="100000"/>
-              <a:buChar char="•"/>
-            </a:pPr>
-            <a:r>
-              <a:rPr lang="en-US" sz="1700" dirty="0">
-                <a:solidFill>
-                  <a:srgbClr val="1B2733"/>
+              <a:t>Japanese neutral review: translate, classify, draft a Japanese reply</a:t>
+            </a:r>
+            <a:endParaRPr lang="en-US" sz="1400" dirty="0"/>
+          </a:p>
+        </p:txBody>
+      </p:sp>
+      <p:sp>
+        <p:nvSpPr>
+          <p:cNvPr id="16" name="Text 14"/>
+          <p:cNvSpPr txBox="1"/>
+          <p:nvPr/>
+        </p:nvSpPr>
+        <p:spPr>
+          <a:xfrm>
+            <a:off x="8686800" y="2487168"/>
+            <a:ext cx="2834640" cy="804672"/>
+          </a:xfrm>
+          <a:prstGeom prst="rect">
+            <a:avLst/>
+          </a:prstGeom>
+          <a:noFill/>
+          <a:ln/>
+        </p:spPr>
+        <p:txBody>
+          <a:bodyPr wrap="square" lIns="0" tIns="0" rIns="0" bIns="0" rtlCol="0" anchor="ctr"/>
+          <a:lstStyle/>
+          <a:p>
+            <a:pPr indent="0" marL="0">
+              <a:buNone/>
+            </a:pPr>
+            <a:r>
+              <a:rPr lang="en-US" sz="1300" i="1" dirty="0">
+                <a:solidFill>
+                  <a:srgbClr val="5A6470"/>
                 </a:solidFill>
                 <a:latin typeface="Calibri" pitchFamily="34" charset="0"/>
                 <a:ea typeface="Calibri" pitchFamily="34" charset="-122"/>
                 <a:cs typeface="Calibri" pitchFamily="34" charset="-120"/>
               </a:rPr>
-              <a:t>Self-updating dashboard and Looker Studio</a:t>
+              <a:t>Answers: Language barrier</a:t>
             </a:r>
             <a:endParaRPr lang="en-US" sz="1300" dirty="0"/>
           </a:p>
-          <a:p>
-            <a:pPr marL="342900" indent="-342900">
-              <a:spcAft>
-                <a:spcPts val="800"/>
-              </a:spcAft>
-              <a:buSzPct val="100000"/>
-              <a:buChar char="•"/>
-            </a:pPr>
-            <a:r>
-              <a:rPr lang="en-US" sz="1700" dirty="0">
+        </p:txBody>
+      </p:sp>
+      <p:sp>
+        <p:nvSpPr>
+          <p:cNvPr id="17" name="Shape 15"/>
+          <p:cNvSpPr/>
+          <p:nvPr/>
+        </p:nvSpPr>
+        <p:spPr>
+          <a:xfrm>
+            <a:off x="548640" y="3419856"/>
+            <a:ext cx="11064240" cy="804672"/>
+          </a:xfrm>
+          <a:prstGeom prst="roundRect">
+            <a:avLst>
+              <a:gd name="adj" fmla="val 11364"/>
+            </a:avLst>
+          </a:prstGeom>
+          <a:solidFill>
+            <a:srgbClr val="EEF2F7"/>
+          </a:solidFill>
+          <a:ln w="12700">
+            <a:solidFill>
+              <a:srgbClr val="EEF2F7"/>
+            </a:solidFill>
+            <a:prstDash val="solid"/>
+          </a:ln>
+        </p:spPr>
+      </p:sp>
+      <p:sp>
+        <p:nvSpPr>
+          <p:cNvPr id="18" name="Shape 16"/>
+          <p:cNvSpPr/>
+          <p:nvPr/>
+        </p:nvSpPr>
+        <p:spPr>
+          <a:xfrm>
+            <a:off x="731520" y="3547872"/>
+            <a:ext cx="548640" cy="548640"/>
+          </a:xfrm>
+          <a:prstGeom prst="ellipse">
+            <a:avLst/>
+          </a:prstGeom>
+          <a:solidFill>
+            <a:srgbClr val="E9A23B"/>
+          </a:solidFill>
+          <a:ln w="12700">
+            <a:solidFill>
+              <a:srgbClr val="E9A23B"/>
+            </a:solidFill>
+            <a:prstDash val="solid"/>
+          </a:ln>
+        </p:spPr>
+      </p:sp>
+      <p:sp>
+        <p:nvSpPr>
+          <p:cNvPr id="19" name="Text 17"/>
+          <p:cNvSpPr txBox="1"/>
+          <p:nvPr/>
+        </p:nvSpPr>
+        <p:spPr>
+          <a:xfrm>
+            <a:off x="731520" y="3547872"/>
+            <a:ext cx="548640" cy="548640"/>
+          </a:xfrm>
+          <a:prstGeom prst="rect">
+            <a:avLst/>
+          </a:prstGeom>
+          <a:noFill/>
+          <a:ln/>
+        </p:spPr>
+        <p:txBody>
+          <a:bodyPr wrap="square" lIns="0" tIns="0" rIns="0" bIns="0" rtlCol="0" anchor="ctr"/>
+          <a:lstStyle/>
+          <a:p>
+            <a:pPr algn="ctr" indent="0" marL="0">
+              <a:buNone/>
+            </a:pPr>
+            <a:r>
+              <a:rPr lang="en-US" sz="1800" b="1" dirty="0">
+                <a:solidFill>
+                  <a:srgbClr val="FFFFFF"/>
+                </a:solidFill>
+                <a:latin typeface="Cambria" pitchFamily="34" charset="0"/>
+                <a:ea typeface="Cambria" pitchFamily="34" charset="-122"/>
+                <a:cs typeface="Cambria" pitchFamily="34" charset="-120"/>
+              </a:rPr>
+              <a:t>3</a:t>
+            </a:r>
+            <a:endParaRPr lang="en-US" sz="1800" dirty="0"/>
+          </a:p>
+        </p:txBody>
+      </p:sp>
+      <p:sp>
+        <p:nvSpPr>
+          <p:cNvPr id="20" name="Text 18"/>
+          <p:cNvSpPr txBox="1"/>
+          <p:nvPr/>
+        </p:nvSpPr>
+        <p:spPr>
+          <a:xfrm>
+            <a:off x="1508760" y="3419856"/>
+            <a:ext cx="1280160" cy="804672"/>
+          </a:xfrm>
+          <a:prstGeom prst="rect">
+            <a:avLst/>
+          </a:prstGeom>
+          <a:noFill/>
+          <a:ln/>
+        </p:spPr>
+        <p:txBody>
+          <a:bodyPr wrap="square" lIns="0" tIns="0" rIns="0" bIns="0" rtlCol="0" anchor="ctr"/>
+          <a:lstStyle/>
+          <a:p>
+            <a:pPr indent="0" marL="0">
+              <a:buNone/>
+            </a:pPr>
+            <a:r>
+              <a:rPr lang="en-US" sz="1500" b="1" dirty="0">
+                <a:solidFill>
+                  <a:srgbClr val="1F3A5F"/>
+                </a:solidFill>
+                <a:latin typeface="Cambria" pitchFamily="34" charset="0"/>
+                <a:ea typeface="Cambria" pitchFamily="34" charset="-122"/>
+                <a:cs typeface="Cambria" pitchFamily="34" charset="-120"/>
+              </a:rPr>
+              <a:t>Hard</a:t>
+            </a:r>
+            <a:endParaRPr lang="en-US" sz="1500" dirty="0"/>
+          </a:p>
+        </p:txBody>
+      </p:sp>
+      <p:sp>
+        <p:nvSpPr>
+          <p:cNvPr id="21" name="Text 19"/>
+          <p:cNvSpPr txBox="1"/>
+          <p:nvPr/>
+        </p:nvSpPr>
+        <p:spPr>
+          <a:xfrm>
+            <a:off x="2834640" y="3419856"/>
+            <a:ext cx="5760720" cy="804672"/>
+          </a:xfrm>
+          <a:prstGeom prst="rect">
+            <a:avLst/>
+          </a:prstGeom>
+          <a:noFill/>
+          <a:ln/>
+        </p:spPr>
+        <p:txBody>
+          <a:bodyPr wrap="square" lIns="0" tIns="0" rIns="0" bIns="0" rtlCol="0" anchor="ctr"/>
+          <a:lstStyle/>
+          <a:p>
+            <a:pPr indent="0" marL="0">
+              <a:buNone/>
+            </a:pPr>
+            <a:r>
+              <a:rPr lang="en-US" sz="1400" dirty="0">
                 <a:solidFill>
                   <a:srgbClr val="1B2733"/>
                 </a:solidFill>
@@ -14564,41 +13896,207 @@
                 <a:ea typeface="Calibri" pitchFamily="34" charset="-122"/>
                 <a:cs typeface="Calibri" pitchFamily="34" charset="-120"/>
               </a:rPr>
-              <a:t>Batch and caching to cut the $2.50 per 1,000 reviews</a:t>
-            </a:r>
-            <a:endParaRPr lang="en-US" sz="1300" dirty="0"/>
-          </a:p>
-          <a:p>
-            <a:pPr marL="342900" indent="-342900">
-              <a:spcAft>
-                <a:spcPts val="800"/>
-              </a:spcAft>
-              <a:buSzPct val="100000"/>
-              <a:buChar char="•"/>
-            </a:pPr>
-            <a:r>
-              <a:rPr lang="en-US" sz="1700" dirty="0">
-                <a:solidFill>
-                  <a:srgbClr val="1B2733"/>
+              <a:t>Run n8n workflow 03 on a six-language batch</a:t>
+            </a:r>
+            <a:endParaRPr lang="en-US" sz="1400" dirty="0"/>
+          </a:p>
+        </p:txBody>
+      </p:sp>
+      <p:sp>
+        <p:nvSpPr>
+          <p:cNvPr id="22" name="Text 20"/>
+          <p:cNvSpPr txBox="1"/>
+          <p:nvPr/>
+        </p:nvSpPr>
+        <p:spPr>
+          <a:xfrm>
+            <a:off x="8686800" y="3419856"/>
+            <a:ext cx="2834640" cy="804672"/>
+          </a:xfrm>
+          <a:prstGeom prst="rect">
+            <a:avLst/>
+          </a:prstGeom>
+          <a:noFill/>
+          <a:ln/>
+        </p:spPr>
+        <p:txBody>
+          <a:bodyPr wrap="square" lIns="0" tIns="0" rIns="0" bIns="0" rtlCol="0" anchor="ctr"/>
+          <a:lstStyle/>
+          <a:p>
+            <a:pPr indent="0" marL="0">
+              <a:buNone/>
+            </a:pPr>
+            <a:r>
+              <a:rPr lang="en-US" sz="1300" i="1" dirty="0">
+                <a:solidFill>
+                  <a:srgbClr val="5A6470"/>
                 </a:solidFill>
                 <a:latin typeface="Calibri" pitchFamily="34" charset="0"/>
                 <a:ea typeface="Calibri" pitchFamily="34" charset="-122"/>
                 <a:cs typeface="Calibri" pitchFamily="34" charset="-120"/>
               </a:rPr>
-              <a:t>More languages; send approved replies by Slack or email</a:t>
+              <a:t>Answers: Manual reading at volume</a:t>
             </a:r>
             <a:endParaRPr lang="en-US" sz="1300" dirty="0"/>
           </a:p>
-          <a:p>
-            <a:pPr marL="342900" indent="-342900">
-              <a:spcAft>
-                <a:spcPts val="800"/>
-              </a:spcAft>
-              <a:buSzPct val="100000"/>
-              <a:buChar char="•"/>
-            </a:pPr>
-            <a:r>
-              <a:rPr lang="en-US" sz="1700" dirty="0">
+        </p:txBody>
+      </p:sp>
+      <p:sp>
+        <p:nvSpPr>
+          <p:cNvPr id="23" name="Shape 21"/>
+          <p:cNvSpPr/>
+          <p:nvPr/>
+        </p:nvSpPr>
+        <p:spPr>
+          <a:xfrm>
+            <a:off x="548640" y="4352544"/>
+            <a:ext cx="11064240" cy="804672"/>
+          </a:xfrm>
+          <a:prstGeom prst="roundRect">
+            <a:avLst>
+              <a:gd name="adj" fmla="val 11364"/>
+            </a:avLst>
+          </a:prstGeom>
+          <a:solidFill>
+            <a:srgbClr val="EEF2F7"/>
+          </a:solidFill>
+          <a:ln w="12700">
+            <a:solidFill>
+              <a:srgbClr val="EEF2F7"/>
+            </a:solidFill>
+            <a:prstDash val="solid"/>
+          </a:ln>
+        </p:spPr>
+      </p:sp>
+      <p:sp>
+        <p:nvSpPr>
+          <p:cNvPr id="24" name="Shape 22"/>
+          <p:cNvSpPr/>
+          <p:nvPr/>
+        </p:nvSpPr>
+        <p:spPr>
+          <a:xfrm>
+            <a:off x="731520" y="4480560"/>
+            <a:ext cx="548640" cy="548640"/>
+          </a:xfrm>
+          <a:prstGeom prst="ellipse">
+            <a:avLst/>
+          </a:prstGeom>
+          <a:solidFill>
+            <a:srgbClr val="E9A23B"/>
+          </a:solidFill>
+          <a:ln w="12700">
+            <a:solidFill>
+              <a:srgbClr val="E9A23B"/>
+            </a:solidFill>
+            <a:prstDash val="solid"/>
+          </a:ln>
+        </p:spPr>
+      </p:sp>
+      <p:sp>
+        <p:nvSpPr>
+          <p:cNvPr id="25" name="Text 23"/>
+          <p:cNvSpPr txBox="1"/>
+          <p:nvPr/>
+        </p:nvSpPr>
+        <p:spPr>
+          <a:xfrm>
+            <a:off x="731520" y="4480560"/>
+            <a:ext cx="548640" cy="548640"/>
+          </a:xfrm>
+          <a:prstGeom prst="rect">
+            <a:avLst/>
+          </a:prstGeom>
+          <a:noFill/>
+          <a:ln/>
+        </p:spPr>
+        <p:txBody>
+          <a:bodyPr wrap="square" lIns="0" tIns="0" rIns="0" bIns="0" rtlCol="0" anchor="ctr"/>
+          <a:lstStyle/>
+          <a:p>
+            <a:pPr algn="ctr" indent="0" marL="0">
+              <a:buNone/>
+            </a:pPr>
+            <a:r>
+              <a:rPr lang="en-US" sz="1800" b="1" dirty="0">
+                <a:solidFill>
+                  <a:srgbClr val="FFFFFF"/>
+                </a:solidFill>
+                <a:latin typeface="Cambria" pitchFamily="34" charset="0"/>
+                <a:ea typeface="Cambria" pitchFamily="34" charset="-122"/>
+                <a:cs typeface="Cambria" pitchFamily="34" charset="-120"/>
+              </a:rPr>
+              <a:t>4</a:t>
+            </a:r>
+            <a:endParaRPr lang="en-US" sz="1800" dirty="0"/>
+          </a:p>
+        </p:txBody>
+      </p:sp>
+      <p:sp>
+        <p:nvSpPr>
+          <p:cNvPr id="26" name="Text 24"/>
+          <p:cNvSpPr txBox="1"/>
+          <p:nvPr/>
+        </p:nvSpPr>
+        <p:spPr>
+          <a:xfrm>
+            <a:off x="1508760" y="4352544"/>
+            <a:ext cx="1280160" cy="804672"/>
+          </a:xfrm>
+          <a:prstGeom prst="rect">
+            <a:avLst/>
+          </a:prstGeom>
+          <a:noFill/>
+          <a:ln/>
+        </p:spPr>
+        <p:txBody>
+          <a:bodyPr wrap="square" lIns="0" tIns="0" rIns="0" bIns="0" rtlCol="0" anchor="ctr"/>
+          <a:lstStyle/>
+          <a:p>
+            <a:pPr indent="0" marL="0">
+              <a:buNone/>
+            </a:pPr>
+            <a:r>
+              <a:rPr lang="en-US" sz="1500" b="1" dirty="0">
+                <a:solidFill>
+                  <a:srgbClr val="1F3A5F"/>
+                </a:solidFill>
+                <a:latin typeface="Cambria" pitchFamily="34" charset="0"/>
+                <a:ea typeface="Cambria" pitchFamily="34" charset="-122"/>
+                <a:cs typeface="Cambria" pitchFamily="34" charset="-120"/>
+              </a:rPr>
+              <a:t>Hard</a:t>
+            </a:r>
+            <a:endParaRPr lang="en-US" sz="1500" dirty="0"/>
+          </a:p>
+        </p:txBody>
+      </p:sp>
+      <p:sp>
+        <p:nvSpPr>
+          <p:cNvPr id="27" name="Text 25"/>
+          <p:cNvSpPr txBox="1"/>
+          <p:nvPr/>
+        </p:nvSpPr>
+        <p:spPr>
+          <a:xfrm>
+            <a:off x="2834640" y="4352544"/>
+            <a:ext cx="5760720" cy="804672"/>
+          </a:xfrm>
+          <a:prstGeom prst="rect">
+            <a:avLst/>
+          </a:prstGeom>
+          <a:noFill/>
+          <a:ln/>
+        </p:spPr>
+        <p:txBody>
+          <a:bodyPr wrap="square" lIns="0" tIns="0" rIns="0" bIns="0" rtlCol="0" anchor="ctr"/>
+          <a:lstStyle/>
+          <a:p>
+            <a:pPr indent="0" marL="0">
+              <a:buNone/>
+            </a:pPr>
+            <a:r>
+              <a:rPr lang="en-US" sz="1400" dirty="0">
                 <a:solidFill>
                   <a:srgbClr val="1B2733"/>
                 </a:solidFill>
@@ -14606,7 +14104,254 @@
                 <a:ea typeface="Calibri" pitchFamily="34" charset="-122"/>
                 <a:cs typeface="Calibri" pitchFamily="34" charset="-120"/>
               </a:rPr>
-              <a:t>Learn from edited replies</a:t>
+              <a:t>The mixed 3-star review about the device that restarts itself</a:t>
+            </a:r>
+            <a:endParaRPr lang="en-US" sz="1400" dirty="0"/>
+          </a:p>
+        </p:txBody>
+      </p:sp>
+      <p:sp>
+        <p:nvSpPr>
+          <p:cNvPr id="28" name="Text 26"/>
+          <p:cNvSpPr txBox="1"/>
+          <p:nvPr/>
+        </p:nvSpPr>
+        <p:spPr>
+          <a:xfrm>
+            <a:off x="8686800" y="4352544"/>
+            <a:ext cx="2834640" cy="804672"/>
+          </a:xfrm>
+          <a:prstGeom prst="rect">
+            <a:avLst/>
+          </a:prstGeom>
+          <a:noFill/>
+          <a:ln/>
+        </p:spPr>
+        <p:txBody>
+          <a:bodyPr wrap="square" lIns="0" tIns="0" rIns="0" bIns="0" rtlCol="0" anchor="ctr"/>
+          <a:lstStyle/>
+          <a:p>
+            <a:pPr indent="0" marL="0">
+              <a:buNone/>
+            </a:pPr>
+            <a:r>
+              <a:rPr lang="en-US" sz="1300" i="1" dirty="0">
+                <a:solidFill>
+                  <a:srgbClr val="5A6470"/>
+                </a:solidFill>
+                <a:latin typeface="Calibri" pitchFamily="34" charset="0"/>
+                <a:ea typeface="Calibri" pitchFamily="34" charset="-122"/>
+                <a:cs typeface="Calibri" pitchFamily="34" charset="-120"/>
+              </a:rPr>
+              <a:t>Answers: Stars hide the reason</a:t>
+            </a:r>
+            <a:endParaRPr lang="en-US" sz="1300" dirty="0"/>
+          </a:p>
+        </p:txBody>
+      </p:sp>
+      <p:sp>
+        <p:nvSpPr>
+          <p:cNvPr id="29" name="Shape 27"/>
+          <p:cNvSpPr/>
+          <p:nvPr/>
+        </p:nvSpPr>
+        <p:spPr>
+          <a:xfrm>
+            <a:off x="548640" y="5285232"/>
+            <a:ext cx="11064240" cy="804672"/>
+          </a:xfrm>
+          <a:prstGeom prst="roundRect">
+            <a:avLst>
+              <a:gd name="adj" fmla="val 11364"/>
+            </a:avLst>
+          </a:prstGeom>
+          <a:solidFill>
+            <a:srgbClr val="EEF2F7"/>
+          </a:solidFill>
+          <a:ln w="12700">
+            <a:solidFill>
+              <a:srgbClr val="EEF2F7"/>
+            </a:solidFill>
+            <a:prstDash val="solid"/>
+          </a:ln>
+        </p:spPr>
+      </p:sp>
+      <p:sp>
+        <p:nvSpPr>
+          <p:cNvPr id="30" name="Shape 28"/>
+          <p:cNvSpPr/>
+          <p:nvPr/>
+        </p:nvSpPr>
+        <p:spPr>
+          <a:xfrm>
+            <a:off x="731520" y="5413248"/>
+            <a:ext cx="548640" cy="548640"/>
+          </a:xfrm>
+          <a:prstGeom prst="ellipse">
+            <a:avLst/>
+          </a:prstGeom>
+          <a:solidFill>
+            <a:srgbClr val="C8553D"/>
+          </a:solidFill>
+          <a:ln w="12700">
+            <a:solidFill>
+              <a:srgbClr val="C8553D"/>
+            </a:solidFill>
+            <a:prstDash val="solid"/>
+          </a:ln>
+        </p:spPr>
+      </p:sp>
+      <p:sp>
+        <p:nvSpPr>
+          <p:cNvPr id="31" name="Text 29"/>
+          <p:cNvSpPr txBox="1"/>
+          <p:nvPr/>
+        </p:nvSpPr>
+        <p:spPr>
+          <a:xfrm>
+            <a:off x="731520" y="5413248"/>
+            <a:ext cx="548640" cy="548640"/>
+          </a:xfrm>
+          <a:prstGeom prst="rect">
+            <a:avLst/>
+          </a:prstGeom>
+          <a:noFill/>
+          <a:ln/>
+        </p:spPr>
+        <p:txBody>
+          <a:bodyPr wrap="square" lIns="0" tIns="0" rIns="0" bIns="0" rtlCol="0" anchor="ctr"/>
+          <a:lstStyle/>
+          <a:p>
+            <a:pPr algn="ctr" indent="0" marL="0">
+              <a:buNone/>
+            </a:pPr>
+            <a:r>
+              <a:rPr lang="en-US" sz="1800" b="1" dirty="0">
+                <a:solidFill>
+                  <a:srgbClr val="FFFFFF"/>
+                </a:solidFill>
+                <a:latin typeface="Cambria" pitchFamily="34" charset="0"/>
+                <a:ea typeface="Cambria" pitchFamily="34" charset="-122"/>
+                <a:cs typeface="Cambria" pitchFamily="34" charset="-120"/>
+              </a:rPr>
+              <a:t>5</a:t>
+            </a:r>
+            <a:endParaRPr lang="en-US" sz="1800" dirty="0"/>
+          </a:p>
+        </p:txBody>
+      </p:sp>
+      <p:sp>
+        <p:nvSpPr>
+          <p:cNvPr id="32" name="Text 30"/>
+          <p:cNvSpPr txBox="1"/>
+          <p:nvPr/>
+        </p:nvSpPr>
+        <p:spPr>
+          <a:xfrm>
+            <a:off x="1508760" y="5285232"/>
+            <a:ext cx="1280160" cy="804672"/>
+          </a:xfrm>
+          <a:prstGeom prst="rect">
+            <a:avLst/>
+          </a:prstGeom>
+          <a:noFill/>
+          <a:ln/>
+        </p:spPr>
+        <p:txBody>
+          <a:bodyPr wrap="square" lIns="0" tIns="0" rIns="0" bIns="0" rtlCol="0" anchor="ctr"/>
+          <a:lstStyle/>
+          <a:p>
+            <a:pPr indent="0" marL="0">
+              <a:buNone/>
+            </a:pPr>
+            <a:r>
+              <a:rPr lang="en-US" sz="1500" b="1" dirty="0">
+                <a:solidFill>
+                  <a:srgbClr val="1F3A5F"/>
+                </a:solidFill>
+                <a:latin typeface="Cambria" pitchFamily="34" charset="0"/>
+                <a:ea typeface="Cambria" pitchFamily="34" charset="-122"/>
+                <a:cs typeface="Cambria" pitchFamily="34" charset="-120"/>
+              </a:rPr>
+              <a:t>Hardest</a:t>
+            </a:r>
+            <a:endParaRPr lang="en-US" sz="1500" dirty="0"/>
+          </a:p>
+        </p:txBody>
+      </p:sp>
+      <p:sp>
+        <p:nvSpPr>
+          <p:cNvPr id="33" name="Text 31"/>
+          <p:cNvSpPr txBox="1"/>
+          <p:nvPr/>
+        </p:nvSpPr>
+        <p:spPr>
+          <a:xfrm>
+            <a:off x="2834640" y="5285232"/>
+            <a:ext cx="5760720" cy="804672"/>
+          </a:xfrm>
+          <a:prstGeom prst="rect">
+            <a:avLst/>
+          </a:prstGeom>
+          <a:noFill/>
+          <a:ln/>
+        </p:spPr>
+        <p:txBody>
+          <a:bodyPr wrap="square" lIns="0" tIns="0" rIns="0" bIns="0" rtlCol="0" anchor="ctr"/>
+          <a:lstStyle/>
+          <a:p>
+            <a:pPr indent="0" marL="0">
+              <a:buNone/>
+            </a:pPr>
+            <a:r>
+              <a:rPr lang="en-US" sz="1400" dirty="0">
+                <a:solidFill>
+                  <a:srgbClr val="1B2733"/>
+                </a:solidFill>
+                <a:latin typeface="Calibri" pitchFamily="34" charset="0"/>
+                <a:ea typeface="Calibri" pitchFamily="34" charset="-122"/>
+                <a:cs typeface="Calibri" pitchFamily="34" charset="-120"/>
+              </a:rPr>
+              <a:t>Run workflow 04: spike found, Slack message arrives</a:t>
+            </a:r>
+            <a:endParaRPr lang="en-US" sz="1400" dirty="0"/>
+          </a:p>
+        </p:txBody>
+      </p:sp>
+      <p:sp>
+        <p:nvSpPr>
+          <p:cNvPr id="34" name="Text 32"/>
+          <p:cNvSpPr txBox="1"/>
+          <p:nvPr/>
+        </p:nvSpPr>
+        <p:spPr>
+          <a:xfrm>
+            <a:off x="8686800" y="5285232"/>
+            <a:ext cx="2834640" cy="804672"/>
+          </a:xfrm>
+          <a:prstGeom prst="rect">
+            <a:avLst/>
+          </a:prstGeom>
+          <a:noFill/>
+          <a:ln/>
+        </p:spPr>
+        <p:txBody>
+          <a:bodyPr wrap="square" lIns="0" tIns="0" rIns="0" bIns="0" rtlCol="0" anchor="ctr"/>
+          <a:lstStyle/>
+          <a:p>
+            <a:pPr indent="0" marL="0">
+              <a:buNone/>
+            </a:pPr>
+            <a:r>
+              <a:rPr lang="en-US" sz="1300" i="1" dirty="0">
+                <a:solidFill>
+                  <a:srgbClr val="5A6470"/>
+                </a:solidFill>
+                <a:latin typeface="Calibri" pitchFamily="34" charset="0"/>
+                <a:ea typeface="Calibri" pitchFamily="34" charset="-122"/>
+                <a:cs typeface="Calibri" pitchFamily="34" charset="-120"/>
+              </a:rPr>
+              <a:t>Answers: Spikes found late</a:t>
             </a:r>
             <a:endParaRPr lang="en-US" sz="1300" dirty="0"/>
           </a:p>
@@ -14725,7 +14470,7 @@
                 <a:ea typeface="Calibri" pitchFamily="34" charset="-122"/>
                 <a:cs typeface="Calibri" pitchFamily="34" charset="-120"/>
               </a:rPr>
-              <a:t>BUSINESS PERSPECTIVE</a:t>
+              <a:t>LIMITATIONS AND FUTURE SCOPE</a:t>
             </a:r>
             <a:endParaRPr lang="en-US" sz="1200" dirty="0"/>
           </a:p>
@@ -14764,7 +14509,7 @@
                 <a:ea typeface="Cambria" pitchFamily="34" charset="-122"/>
                 <a:cs typeface="Cambria" pitchFamily="34" charset="-120"/>
               </a:rPr>
-              <a:t>Business view: cheap, fast, and a human stays in charge</a:t>
+              <a:t>Limitations and where we go next</a:t>
             </a:r>
             <a:endParaRPr lang="en-US" sz="3000" dirty="0"/>
           </a:p>
@@ -14811,14 +14556,41 @@
       </p:sp>
       <p:sp>
         <p:nvSpPr>
-          <p:cNvPr id="5" name="Text 3"/>
+          <p:cNvPr id="5" name="Shape 3"/>
+          <p:cNvSpPr/>
+          <p:nvPr/>
+        </p:nvSpPr>
+        <p:spPr>
+          <a:xfrm>
+            <a:off x="548640" y="1554480"/>
+            <a:ext cx="5394960" cy="4480560"/>
+          </a:xfrm>
+          <a:prstGeom prst="roundRect">
+            <a:avLst>
+              <a:gd name="adj" fmla="val 2041"/>
+            </a:avLst>
+          </a:prstGeom>
+          <a:solidFill>
+            <a:srgbClr val="FFF4DC"/>
+          </a:solidFill>
+          <a:ln w="12700">
+            <a:solidFill>
+              <a:srgbClr val="FFF4DC"/>
+            </a:solidFill>
+            <a:prstDash val="solid"/>
+          </a:ln>
+        </p:spPr>
+      </p:sp>
+      <p:sp>
+        <p:nvSpPr>
+          <p:cNvPr id="6" name="Text 4"/>
           <p:cNvSpPr txBox="1"/>
           <p:nvPr/>
         </p:nvSpPr>
         <p:spPr>
           <a:xfrm>
-            <a:off x="548640" y="1554480"/>
-            <a:ext cx="3474720" cy="822960"/>
+            <a:off x="731520" y="1691640"/>
+            <a:ext cx="5029200" cy="365760"/>
           </a:xfrm>
           <a:prstGeom prst="rect">
             <a:avLst/>
@@ -14827,37 +14599,37 @@
           <a:ln/>
         </p:spPr>
         <p:txBody>
-          <a:bodyPr wrap="square" lIns="0" tIns="0" rIns="0" bIns="0" rtlCol="0" anchor="ctr"/>
+          <a:bodyPr wrap="square" lIns="0" tIns="0" rIns="0" bIns="0" rtlCol="0" anchor="t"/>
           <a:lstStyle/>
           <a:p>
             <a:pPr indent="0" marL="0">
               <a:buNone/>
             </a:pPr>
             <a:r>
-              <a:rPr lang="en-US" sz="4400" b="1" dirty="0">
-                <a:solidFill>
-                  <a:srgbClr val="2A9D8F"/>
+              <a:rPr lang="en-US" sz="1600" b="1" dirty="0">
+                <a:solidFill>
+                  <a:srgbClr val="1F3A5F"/>
                 </a:solidFill>
                 <a:latin typeface="Cambria" pitchFamily="34" charset="0"/>
                 <a:ea typeface="Cambria" pitchFamily="34" charset="-122"/>
                 <a:cs typeface="Cambria" pitchFamily="34" charset="-120"/>
               </a:rPr>
-              <a:t>$75</a:t>
-            </a:r>
-            <a:endParaRPr lang="en-US" sz="4400" dirty="0"/>
-          </a:p>
-        </p:txBody>
-      </p:sp>
-      <p:sp>
-        <p:nvSpPr>
-          <p:cNvPr id="6" name="Text 4"/>
+              <a:t>Limitations</a:t>
+            </a:r>
+            <a:endParaRPr lang="en-US" sz="1600" dirty="0"/>
+          </a:p>
+        </p:txBody>
+      </p:sp>
+      <p:sp>
+        <p:nvSpPr>
+          <p:cNvPr id="7" name="Text 5"/>
           <p:cNvSpPr txBox="1"/>
           <p:nvPr/>
         </p:nvSpPr>
         <p:spPr>
           <a:xfrm>
-            <a:off x="548640" y="2377440"/>
-            <a:ext cx="3474720" cy="640080"/>
+            <a:off x="731520" y="2103120"/>
+            <a:ext cx="5029200" cy="3794760"/>
           </a:xfrm>
           <a:prstGeom prst="rect">
             <a:avLst/>
@@ -14869,11 +14641,15 @@
           <a:bodyPr wrap="square" lIns="0" tIns="0" rIns="0" bIns="0" rtlCol="0" anchor="t"/>
           <a:lstStyle/>
           <a:p>
-            <a:pPr indent="0" marL="0">
-              <a:buNone/>
-            </a:pPr>
-            <a:r>
-              <a:rPr lang="en-US" sz="1300" dirty="0">
+            <a:pPr marL="342900" indent="-342900">
+              <a:spcAft>
+                <a:spcPts val="800"/>
+              </a:spcAft>
+              <a:buSzPct val="100000"/>
+              <a:buChar char="•"/>
+            </a:pPr>
+            <a:r>
+              <a:rPr lang="en-US" sz="1700" dirty="0">
                 <a:solidFill>
                   <a:srgbClr val="1B2733"/>
                 </a:solidFill>
@@ -14881,77 +14657,20 @@
                 <a:ea typeface="Calibri" pitchFamily="34" charset="-122"/>
                 <a:cs typeface="Calibri" pitchFamily="34" charset="-120"/>
               </a:rPr>
-              <a:t>per month of model usage at 1,000 reviews a day</a:t>
+              <a:t>Simulated dates; threshold tuned on the same simulation</a:t>
             </a:r>
             <a:endParaRPr lang="en-US" sz="1300" dirty="0"/>
           </a:p>
-        </p:txBody>
-      </p:sp>
-      <p:sp>
-        <p:nvSpPr>
-          <p:cNvPr id="7" name="Text 5"/>
-          <p:cNvSpPr txBox="1"/>
-          <p:nvPr/>
-        </p:nvSpPr>
-        <p:spPr>
-          <a:xfrm>
-            <a:off x="4297680" y="1554480"/>
-            <a:ext cx="3474720" cy="822960"/>
-          </a:xfrm>
-          <a:prstGeom prst="rect">
-            <a:avLst/>
-          </a:prstGeom>
-          <a:noFill/>
-          <a:ln/>
-        </p:spPr>
-        <p:txBody>
-          <a:bodyPr wrap="square" lIns="0" tIns="0" rIns="0" bIns="0" rtlCol="0" anchor="ctr"/>
-          <a:lstStyle/>
-          <a:p>
-            <a:pPr indent="0" marL="0">
-              <a:buNone/>
-            </a:pPr>
-            <a:r>
-              <a:rPr lang="en-US" sz="4400" b="1" dirty="0">
-                <a:solidFill>
-                  <a:srgbClr val="1F3A5F"/>
-                </a:solidFill>
-                <a:latin typeface="Cambria" pitchFamily="34" charset="0"/>
-                <a:ea typeface="Cambria" pitchFamily="34" charset="-122"/>
-                <a:cs typeface="Cambria" pitchFamily="34" charset="-120"/>
-              </a:rPr>
-              <a:t>11 min</a:t>
-            </a:r>
-            <a:endParaRPr lang="en-US" sz="4400" dirty="0"/>
-          </a:p>
-        </p:txBody>
-      </p:sp>
-      <p:sp>
-        <p:nvSpPr>
-          <p:cNvPr id="8" name="Text 6"/>
-          <p:cNvSpPr txBox="1"/>
-          <p:nvPr/>
-        </p:nvSpPr>
-        <p:spPr>
-          <a:xfrm>
-            <a:off x="4297680" y="2377440"/>
-            <a:ext cx="3474720" cy="640080"/>
-          </a:xfrm>
-          <a:prstGeom prst="rect">
-            <a:avLst/>
-          </a:prstGeom>
-          <a:noFill/>
-          <a:ln/>
-        </p:spPr>
-        <p:txBody>
-          <a:bodyPr wrap="square" lIns="0" tIns="0" rIns="0" bIns="0" rtlCol="0" anchor="t"/>
-          <a:lstStyle/>
-          <a:p>
-            <a:pPr indent="0" marL="0">
-              <a:buNone/>
-            </a:pPr>
-            <a:r>
-              <a:rPr lang="en-US" sz="1300" dirty="0">
+          <a:p>
+            <a:pPr marL="342900" indent="-342900">
+              <a:spcAft>
+                <a:spcPts val="800"/>
+              </a:spcAft>
+              <a:buSzPct val="100000"/>
+              <a:buChar char="•"/>
+            </a:pPr>
+            <a:r>
+              <a:rPr lang="en-US" sz="1700" dirty="0">
                 <a:solidFill>
                   <a:srgbClr val="1B2733"/>
                 </a:solidFill>
@@ -14959,77 +14678,20 @@
                 <a:ea typeface="Calibri" pitchFamily="34" charset="-122"/>
                 <a:cs typeface="Calibri" pitchFamily="34" charset="-120"/>
               </a:rPr>
-              <a:t>of automated processing for a day's 1,000 reviews</a:t>
+              <a:t>Three-way sentiment 78.1%, neutral class weak</a:t>
             </a:r>
             <a:endParaRPr lang="en-US" sz="1300" dirty="0"/>
           </a:p>
-        </p:txBody>
-      </p:sp>
-      <p:sp>
-        <p:nvSpPr>
-          <p:cNvPr id="9" name="Text 7"/>
-          <p:cNvSpPr txBox="1"/>
-          <p:nvPr/>
-        </p:nvSpPr>
-        <p:spPr>
-          <a:xfrm>
-            <a:off x="8046720" y="1554480"/>
-            <a:ext cx="3566160" cy="822960"/>
-          </a:xfrm>
-          <a:prstGeom prst="rect">
-            <a:avLst/>
-          </a:prstGeom>
-          <a:noFill/>
-          <a:ln/>
-        </p:spPr>
-        <p:txBody>
-          <a:bodyPr wrap="square" lIns="0" tIns="0" rIns="0" bIns="0" rtlCol="0" anchor="ctr"/>
-          <a:lstStyle/>
-          <a:p>
-            <a:pPr indent="0" marL="0">
-              <a:buNone/>
-            </a:pPr>
-            <a:r>
-              <a:rPr lang="en-US" sz="4400" b="1" dirty="0">
-                <a:solidFill>
-                  <a:srgbClr val="E9A23B"/>
-                </a:solidFill>
-                <a:latin typeface="Cambria" pitchFamily="34" charset="0"/>
-                <a:ea typeface="Cambria" pitchFamily="34" charset="-122"/>
-                <a:cs typeface="Cambria" pitchFamily="34" charset="-120"/>
-              </a:rPr>
-              <a:t>~33 h</a:t>
-            </a:r>
-            <a:endParaRPr lang="en-US" sz="4400" dirty="0"/>
-          </a:p>
-        </p:txBody>
-      </p:sp>
-      <p:sp>
-        <p:nvSpPr>
-          <p:cNvPr id="10" name="Text 8"/>
-          <p:cNvSpPr txBox="1"/>
-          <p:nvPr/>
-        </p:nvSpPr>
-        <p:spPr>
-          <a:xfrm>
-            <a:off x="8046720" y="2377440"/>
-            <a:ext cx="3566160" cy="640080"/>
-          </a:xfrm>
-          <a:prstGeom prst="rect">
-            <a:avLst/>
-          </a:prstGeom>
-          <a:noFill/>
-          <a:ln/>
-        </p:spPr>
-        <p:txBody>
-          <a:bodyPr wrap="square" lIns="0" tIns="0" rIns="0" bIns="0" rtlCol="0" anchor="t"/>
-          <a:lstStyle/>
-          <a:p>
-            <a:pPr indent="0" marL="0">
-              <a:buNone/>
-            </a:pPr>
-            <a:r>
-              <a:rPr lang="en-US" sz="1300" dirty="0">
+          <a:p>
+            <a:pPr marL="342900" indent="-342900">
+              <a:spcAft>
+                <a:spcPts val="800"/>
+              </a:spcAft>
+              <a:buSzPct val="100000"/>
+              <a:buChar char="•"/>
+            </a:pPr>
+            <a:r>
+              <a:rPr lang="en-US" sz="1700" dirty="0">
                 <a:solidFill>
                   <a:srgbClr val="1B2733"/>
                 </a:solidFill>
@@ -15037,26 +14699,110 @@
                 <a:ea typeface="Calibri" pitchFamily="34" charset="-122"/>
                 <a:cs typeface="Calibri" pitchFamily="34" charset="-120"/>
               </a:rPr>
-              <a:t>of manual work for the same reviews at 2 min each (assumption)</a:t>
+              <a:t>No human test of reply quality</a:t>
             </a:r>
             <a:endParaRPr lang="en-US" sz="1300" dirty="0"/>
           </a:p>
-        </p:txBody>
-      </p:sp>
-      <p:sp>
-        <p:nvSpPr>
-          <p:cNvPr id="11" name="Shape 9"/>
+          <a:p>
+            <a:pPr marL="342900" indent="-342900">
+              <a:spcAft>
+                <a:spcPts val="800"/>
+              </a:spcAft>
+              <a:buSzPct val="100000"/>
+              <a:buChar char="•"/>
+            </a:pPr>
+            <a:r>
+              <a:rPr lang="en-US" sz="1700" dirty="0">
+                <a:solidFill>
+                  <a:srgbClr val="1B2733"/>
+                </a:solidFill>
+                <a:latin typeface="Calibri" pitchFamily="34" charset="0"/>
+                <a:ea typeface="Calibri" pitchFamily="34" charset="-122"/>
+                <a:cs typeface="Calibri" pitchFamily="34" charset="-120"/>
+              </a:rPr>
+              <a:t>Neutral and Japanese replies are weakest</a:t>
+            </a:r>
+            <a:endParaRPr lang="en-US" sz="1300" dirty="0"/>
+          </a:p>
+          <a:p>
+            <a:pPr marL="342900" indent="-342900">
+              <a:spcAft>
+                <a:spcPts val="800"/>
+              </a:spcAft>
+              <a:buSzPct val="100000"/>
+              <a:buChar char="•"/>
+            </a:pPr>
+            <a:r>
+              <a:rPr lang="en-US" sz="1700" dirty="0">
+                <a:solidFill>
+                  <a:srgbClr val="1B2733"/>
+                </a:solidFill>
+                <a:latin typeface="Calibri" pitchFamily="34" charset="0"/>
+                <a:ea typeface="Calibri" pitchFamily="34" charset="-122"/>
+                <a:cs typeface="Calibri" pitchFamily="34" charset="-120"/>
+              </a:rPr>
+              <a:t>Issue categories in n8n agree 43% with k-means</a:t>
+            </a:r>
+            <a:endParaRPr lang="en-US" sz="1300" dirty="0"/>
+          </a:p>
+          <a:p>
+            <a:pPr marL="342900" indent="-342900">
+              <a:spcAft>
+                <a:spcPts val="800"/>
+              </a:spcAft>
+              <a:buSzPct val="100000"/>
+              <a:buChar char="•"/>
+            </a:pPr>
+            <a:r>
+              <a:rPr lang="en-US" sz="1700" dirty="0">
+                <a:solidFill>
+                  <a:srgbClr val="1B2733"/>
+                </a:solidFill>
+                <a:latin typeface="Calibri" pitchFamily="34" charset="0"/>
+                <a:ea typeface="Calibri" pitchFamily="34" charset="-122"/>
+                <a:cs typeface="Calibri" pitchFamily="34" charset="-120"/>
+              </a:rPr>
+              <a:t>Small test sets; results move by a few points</a:t>
+            </a:r>
+            <a:endParaRPr lang="en-US" sz="1300" dirty="0"/>
+          </a:p>
+          <a:p>
+            <a:pPr marL="342900" indent="-342900">
+              <a:spcAft>
+                <a:spcPts val="800"/>
+              </a:spcAft>
+              <a:buSzPct val="100000"/>
+              <a:buChar char="•"/>
+            </a:pPr>
+            <a:r>
+              <a:rPr lang="en-US" sz="1700" dirty="0">
+                <a:solidFill>
+                  <a:srgbClr val="1B2733"/>
+                </a:solidFill>
+                <a:latin typeface="Calibri" pitchFamily="34" charset="0"/>
+                <a:ea typeface="Calibri" pitchFamily="34" charset="-122"/>
+                <a:cs typeface="Calibri" pitchFamily="34" charset="-120"/>
+              </a:rPr>
+              <a:t>Sheet updated by paste; n8n runs start by hand</a:t>
+            </a:r>
+            <a:endParaRPr lang="en-US" sz="1300" dirty="0"/>
+          </a:p>
+        </p:txBody>
+      </p:sp>
+      <p:sp>
+        <p:nvSpPr>
+          <p:cNvPr id="8" name="Shape 6"/>
           <p:cNvSpPr/>
           <p:nvPr/>
         </p:nvSpPr>
         <p:spPr>
           <a:xfrm>
-            <a:off x="548640" y="3566160"/>
-            <a:ext cx="5394960" cy="2606040"/>
+            <a:off x="6217920" y="1554480"/>
+            <a:ext cx="5394960" cy="4480560"/>
           </a:xfrm>
           <a:prstGeom prst="roundRect">
             <a:avLst>
-              <a:gd name="adj" fmla="val 3509"/>
+              <a:gd name="adj" fmla="val 2041"/>
             </a:avLst>
           </a:prstGeom>
           <a:solidFill>
@@ -15072,13 +14818,13 @@
       </p:sp>
       <p:sp>
         <p:nvSpPr>
-          <p:cNvPr id="12" name="Text 10"/>
+          <p:cNvPr id="9" name="Text 7"/>
           <p:cNvSpPr txBox="1"/>
           <p:nvPr/>
         </p:nvSpPr>
         <p:spPr>
           <a:xfrm>
-            <a:off x="731520" y="3703320"/>
+            <a:off x="6400800" y="1691640"/>
             <a:ext cx="5029200" cy="365760"/>
           </a:xfrm>
           <a:prstGeom prst="rect">
@@ -15103,7 +14849,7 @@
                 <a:ea typeface="Cambria" pitchFamily="34" charset="-122"/>
                 <a:cs typeface="Cambria" pitchFamily="34" charset="-120"/>
               </a:rPr>
-              <a:t>Value</a:t>
+              <a:t>Future scope and scaling</a:t>
             </a:r>
             <a:endParaRPr lang="en-US" sz="1600" dirty="0"/>
           </a:p>
@@ -15111,14 +14857,14 @@
       </p:sp>
       <p:sp>
         <p:nvSpPr>
-          <p:cNvPr id="13" name="Text 11"/>
+          <p:cNvPr id="10" name="Text 8"/>
           <p:cNvSpPr txBox="1"/>
           <p:nvPr/>
         </p:nvSpPr>
         <p:spPr>
           <a:xfrm>
-            <a:off x="731520" y="4114800"/>
-            <a:ext cx="5029200" cy="1920240"/>
+            <a:off x="6400800" y="2103120"/>
+            <a:ext cx="5029200" cy="3794760"/>
           </a:xfrm>
           <a:prstGeom prst="rect">
             <a:avLst/>
@@ -15138,7 +14884,7 @@
               <a:buChar char="•"/>
             </a:pPr>
             <a:r>
-              <a:rPr lang="en-US" sz="1600" dirty="0">
+              <a:rPr lang="en-US" sz="1700" dirty="0">
                 <a:solidFill>
                   <a:srgbClr val="1B2733"/>
                 </a:solidFill>
@@ -15146,7 +14892,7 @@
                 <a:ea typeface="Calibri" pitchFamily="34" charset="-122"/>
                 <a:cs typeface="Calibri" pitchFamily="34" charset="-120"/>
               </a:rPr>
-              <a:t>Replies in the customer's own language</a:t>
+              <a:t>Connect a real dated review feed and retune spikes</a:t>
             </a:r>
             <a:endParaRPr lang="en-US" sz="1300" dirty="0"/>
           </a:p>
@@ -15159,7 +14905,7 @@
               <a:buChar char="•"/>
             </a:pPr>
             <a:r>
-              <a:rPr lang="en-US" sz="1600" dirty="0">
+              <a:rPr lang="en-US" sz="1700" dirty="0">
                 <a:solidFill>
                   <a:srgbClr val="1B2733"/>
                 </a:solidFill>
@@ -15167,7 +14913,7 @@
                 <a:ea typeface="Calibri" pitchFamily="34" charset="-122"/>
                 <a:cs typeface="Calibri" pitchFamily="34" charset="-120"/>
               </a:rPr>
-              <a:t>Early warning on delivery, packaging and price problems</a:t>
+              <a:t>Human evaluation with support staff</a:t>
             </a:r>
             <a:endParaRPr lang="en-US" sz="1300" dirty="0"/>
           </a:p>
@@ -15180,7 +14926,7 @@
               <a:buChar char="•"/>
             </a:pPr>
             <a:r>
-              <a:rPr lang="en-US" sz="1600" dirty="0">
+              <a:rPr lang="en-US" sz="1700" dirty="0">
                 <a:solidFill>
                   <a:srgbClr val="1B2733"/>
                 </a:solidFill>
@@ -15188,98 +14934,10 @@
                 <a:ea typeface="Calibri" pitchFamily="34" charset="-122"/>
                 <a:cs typeface="Calibri" pitchFamily="34" charset="-120"/>
               </a:rPr>
-              <a:t>Shared view of why customers rate low</a:t>
+              <a:t>Add a separate 'mixed' flag for neutral reviews</a:t>
             </a:r>
             <a:endParaRPr lang="en-US" sz="1300" dirty="0"/>
           </a:p>
-        </p:txBody>
-      </p:sp>
-      <p:sp>
-        <p:nvSpPr>
-          <p:cNvPr id="14" name="Shape 12"/>
-          <p:cNvSpPr/>
-          <p:nvPr/>
-        </p:nvSpPr>
-        <p:spPr>
-          <a:xfrm>
-            <a:off x="6217920" y="3566160"/>
-            <a:ext cx="5394960" cy="2606040"/>
-          </a:xfrm>
-          <a:prstGeom prst="roundRect">
-            <a:avLst>
-              <a:gd name="adj" fmla="val 3509"/>
-            </a:avLst>
-          </a:prstGeom>
-          <a:solidFill>
-            <a:srgbClr val="EEF2F7"/>
-          </a:solidFill>
-          <a:ln w="12700">
-            <a:solidFill>
-              <a:srgbClr val="EEF2F7"/>
-            </a:solidFill>
-            <a:prstDash val="solid"/>
-          </a:ln>
-        </p:spPr>
-      </p:sp>
-      <p:sp>
-        <p:nvSpPr>
-          <p:cNvPr id="15" name="Text 13"/>
-          <p:cNvSpPr txBox="1"/>
-          <p:nvPr/>
-        </p:nvSpPr>
-        <p:spPr>
-          <a:xfrm>
-            <a:off x="6400800" y="3703320"/>
-            <a:ext cx="5029200" cy="365760"/>
-          </a:xfrm>
-          <a:prstGeom prst="rect">
-            <a:avLst/>
-          </a:prstGeom>
-          <a:noFill/>
-          <a:ln/>
-        </p:spPr>
-        <p:txBody>
-          <a:bodyPr wrap="square" lIns="0" tIns="0" rIns="0" bIns="0" rtlCol="0" anchor="t"/>
-          <a:lstStyle/>
-          <a:p>
-            <a:pPr indent="0" marL="0">
-              <a:buNone/>
-            </a:pPr>
-            <a:r>
-              <a:rPr lang="en-US" sz="1600" b="1" dirty="0">
-                <a:solidFill>
-                  <a:srgbClr val="1F3A5F"/>
-                </a:solidFill>
-                <a:latin typeface="Cambria" pitchFamily="34" charset="0"/>
-                <a:ea typeface="Cambria" pitchFamily="34" charset="-122"/>
-                <a:cs typeface="Cambria" pitchFamily="34" charset="-120"/>
-              </a:rPr>
-              <a:t>Risks we manage</a:t>
-            </a:r>
-            <a:endParaRPr lang="en-US" sz="1600" dirty="0"/>
-          </a:p>
-        </p:txBody>
-      </p:sp>
-      <p:sp>
-        <p:nvSpPr>
-          <p:cNvPr id="16" name="Text 14"/>
-          <p:cNvSpPr txBox="1"/>
-          <p:nvPr/>
-        </p:nvSpPr>
-        <p:spPr>
-          <a:xfrm>
-            <a:off x="6400800" y="4114800"/>
-            <a:ext cx="5029200" cy="1920240"/>
-          </a:xfrm>
-          <a:prstGeom prst="rect">
-            <a:avLst/>
-          </a:prstGeom>
-          <a:noFill/>
-          <a:ln/>
-        </p:spPr>
-        <p:txBody>
-          <a:bodyPr wrap="square" lIns="0" tIns="0" rIns="0" bIns="0" rtlCol="0" anchor="t"/>
-          <a:lstStyle/>
           <a:p>
             <a:pPr marL="342900" indent="-342900">
               <a:spcAft>
@@ -15289,7 +14947,7 @@
               <a:buChar char="•"/>
             </a:pPr>
             <a:r>
-              <a:rPr lang="en-US" sz="1600" dirty="0">
+              <a:rPr lang="en-US" sz="1700" dirty="0">
                 <a:solidFill>
                   <a:srgbClr val="1B2733"/>
                 </a:solidFill>
@@ -15297,7 +14955,7 @@
                 <a:ea typeface="Calibri" pitchFamily="34" charset="-122"/>
                 <a:cs typeface="Calibri" pitchFamily="34" charset="-120"/>
               </a:rPr>
-              <a:t>Over-promising replies: guardrails, judge, human approval</a:t>
+              <a:t>Self-updating dashboard and Looker Studio</a:t>
             </a:r>
             <a:endParaRPr lang="en-US" sz="1300" dirty="0"/>
           </a:p>
@@ -15310,7 +14968,7 @@
               <a:buChar char="•"/>
             </a:pPr>
             <a:r>
-              <a:rPr lang="en-US" sz="1600" dirty="0">
+              <a:rPr lang="en-US" sz="1700" dirty="0">
                 <a:solidFill>
                   <a:srgbClr val="1B2733"/>
                 </a:solidFill>
@@ -15318,7 +14976,7 @@
                 <a:ea typeface="Calibri" pitchFamily="34" charset="-122"/>
                 <a:cs typeface="Calibri" pitchFamily="34" charset="-120"/>
               </a:rPr>
-              <a:t>Cost surprises: spend cap and call log</a:t>
+              <a:t>Batch and caching to cut the $2.50 per 1,000 reviews</a:t>
             </a:r>
             <a:endParaRPr lang="en-US" sz="1300" dirty="0"/>
           </a:p>
@@ -15331,7 +14989,7 @@
               <a:buChar char="•"/>
             </a:pPr>
             <a:r>
-              <a:rPr lang="en-US" sz="1600" dirty="0">
+              <a:rPr lang="en-US" sz="1700" dirty="0">
                 <a:solidFill>
                   <a:srgbClr val="1B2733"/>
                 </a:solidFill>
@@ -15339,7 +14997,28 @@
                 <a:ea typeface="Calibri" pitchFamily="34" charset="-122"/>
                 <a:cs typeface="Calibri" pitchFamily="34" charset="-120"/>
               </a:rPr>
-              <a:t>Weak neutral sentiment: flag borderline reviews</a:t>
+              <a:t>More languages; send approved replies by Slack or email</a:t>
+            </a:r>
+            <a:endParaRPr lang="en-US" sz="1300" dirty="0"/>
+          </a:p>
+          <a:p>
+            <a:pPr marL="342900" indent="-342900">
+              <a:spcAft>
+                <a:spcPts val="800"/>
+              </a:spcAft>
+              <a:buSzPct val="100000"/>
+              <a:buChar char="•"/>
+            </a:pPr>
+            <a:r>
+              <a:rPr lang="en-US" sz="1700" dirty="0">
+                <a:solidFill>
+                  <a:srgbClr val="1B2733"/>
+                </a:solidFill>
+                <a:latin typeface="Calibri" pitchFamily="34" charset="0"/>
+                <a:ea typeface="Calibri" pitchFamily="34" charset="-122"/>
+                <a:cs typeface="Calibri" pitchFamily="34" charset="-120"/>
+              </a:rPr>
+              <a:t>Learn from edited replies</a:t>
             </a:r>
             <a:endParaRPr lang="en-US" sz="1300" dirty="0"/>
           </a:p>
@@ -16707,6 +16386,739 @@
 <file path=ppt/slides/slide20.xml><?xml version="1.0" encoding="utf-8"?>
 <p:sld xmlns:a="http://schemas.openxmlformats.org/drawingml/2006/main" xmlns:r="http://schemas.openxmlformats.org/officeDocument/2006/relationships" xmlns:p="http://schemas.openxmlformats.org/presentationml/2006/main">
   <p:cSld name="Slide 20">
+    <p:bg>
+      <p:bgPr>
+        <a:solidFill>
+          <a:srgbClr val="FFFFFF"/>
+        </a:solidFill>
+      </p:bgPr>
+    </p:bg>
+    <p:spTree>
+      <p:nvGrpSpPr>
+        <p:cNvPr id="1" name=""/>
+        <p:cNvGrpSpPr/>
+        <p:nvPr/>
+      </p:nvGrpSpPr>
+      <p:grpSpPr>
+        <a:xfrm>
+          <a:off x="0" y="0"/>
+          <a:ext cx="0" cy="0"/>
+          <a:chOff x="0" y="0"/>
+          <a:chExt cx="0" cy="0"/>
+        </a:xfrm>
+      </p:grpSpPr>
+      <p:sp>
+        <p:nvSpPr>
+          <p:cNvPr id="2" name="Text 0"/>
+          <p:cNvSpPr txBox="1"/>
+          <p:nvPr/>
+        </p:nvSpPr>
+        <p:spPr>
+          <a:xfrm>
+            <a:off x="548640" y="320040"/>
+            <a:ext cx="8229600" cy="274320"/>
+          </a:xfrm>
+          <a:prstGeom prst="rect">
+            <a:avLst/>
+          </a:prstGeom>
+          <a:noFill/>
+          <a:ln/>
+        </p:spPr>
+        <p:txBody>
+          <a:bodyPr wrap="square" lIns="0" tIns="0" rIns="0" bIns="0" rtlCol="0" anchor="ctr"/>
+          <a:lstStyle/>
+          <a:p>
+            <a:pPr indent="0" marL="0">
+              <a:buNone/>
+            </a:pPr>
+            <a:r>
+              <a:rPr lang="en-US" sz="1200" b="1" spc="200" kern="0" dirty="0">
+                <a:solidFill>
+                  <a:srgbClr val="2A9D8F"/>
+                </a:solidFill>
+                <a:latin typeface="Calibri" pitchFamily="34" charset="0"/>
+                <a:ea typeface="Calibri" pitchFamily="34" charset="-122"/>
+                <a:cs typeface="Calibri" pitchFamily="34" charset="-120"/>
+              </a:rPr>
+              <a:t>BUSINESS PERSPECTIVE</a:t>
+            </a:r>
+            <a:endParaRPr lang="en-US" sz="1200" dirty="0"/>
+          </a:p>
+        </p:txBody>
+      </p:sp>
+      <p:sp>
+        <p:nvSpPr>
+          <p:cNvPr id="3" name="Text 1"/>
+          <p:cNvSpPr txBox="1"/>
+          <p:nvPr/>
+        </p:nvSpPr>
+        <p:spPr>
+          <a:xfrm>
+            <a:off x="548640" y="594360"/>
+            <a:ext cx="11064240" cy="777240"/>
+          </a:xfrm>
+          <a:prstGeom prst="rect">
+            <a:avLst/>
+          </a:prstGeom>
+          <a:noFill/>
+          <a:ln/>
+        </p:spPr>
+        <p:txBody>
+          <a:bodyPr wrap="square" lIns="0" tIns="0" rIns="0" bIns="0" rtlCol="0" anchor="t"/>
+          <a:lstStyle/>
+          <a:p>
+            <a:pPr indent="0" marL="0">
+              <a:buNone/>
+            </a:pPr>
+            <a:r>
+              <a:rPr lang="en-US" sz="3000" b="1" dirty="0">
+                <a:solidFill>
+                  <a:srgbClr val="1F3A5F"/>
+                </a:solidFill>
+                <a:latin typeface="Cambria" pitchFamily="34" charset="0"/>
+                <a:ea typeface="Cambria" pitchFamily="34" charset="-122"/>
+                <a:cs typeface="Cambria" pitchFamily="34" charset="-120"/>
+              </a:rPr>
+              <a:t>Business view: cheap, fast, and a human stays in charge</a:t>
+            </a:r>
+            <a:endParaRPr lang="en-US" sz="3000" dirty="0"/>
+          </a:p>
+        </p:txBody>
+      </p:sp>
+      <p:sp>
+        <p:nvSpPr>
+          <p:cNvPr id="4" name="Text 2"/>
+          <p:cNvSpPr txBox="1"/>
+          <p:nvPr/>
+        </p:nvSpPr>
+        <p:spPr>
+          <a:xfrm>
+            <a:off x="548640" y="6446520"/>
+            <a:ext cx="7315200" cy="274320"/>
+          </a:xfrm>
+          <a:prstGeom prst="rect">
+            <a:avLst/>
+          </a:prstGeom>
+          <a:noFill/>
+          <a:ln/>
+        </p:spPr>
+        <p:txBody>
+          <a:bodyPr wrap="square" lIns="0" tIns="0" rIns="0" bIns="0" rtlCol="0" anchor="ctr"/>
+          <a:lstStyle/>
+          <a:p>
+            <a:pPr indent="0" marL="0">
+              <a:buNone/>
+            </a:pPr>
+            <a:r>
+              <a:rPr lang="en-US" sz="1000" dirty="0">
+                <a:solidFill>
+                  <a:srgbClr val="5A6470"/>
+                </a:solidFill>
+                <a:latin typeface="Calibri" pitchFamily="34" charset="0"/>
+                <a:ea typeface="Calibri" pitchFamily="34" charset="-122"/>
+                <a:cs typeface="Calibri" pitchFamily="34" charset="-120"/>
+              </a:rPr>
+              <a:t>Group 5  |  Customer Review Insights &amp; Response Generator</a:t>
+            </a:r>
+            <a:endParaRPr lang="en-US" sz="1000" dirty="0"/>
+          </a:p>
+        </p:txBody>
+      </p:sp>
+      <p:sp>
+        <p:nvSpPr>
+          <p:cNvPr id="5" name="Text 3"/>
+          <p:cNvSpPr txBox="1"/>
+          <p:nvPr/>
+        </p:nvSpPr>
+        <p:spPr>
+          <a:xfrm>
+            <a:off x="548640" y="1554480"/>
+            <a:ext cx="3474720" cy="822960"/>
+          </a:xfrm>
+          <a:prstGeom prst="rect">
+            <a:avLst/>
+          </a:prstGeom>
+          <a:noFill/>
+          <a:ln/>
+        </p:spPr>
+        <p:txBody>
+          <a:bodyPr wrap="square" lIns="0" tIns="0" rIns="0" bIns="0" rtlCol="0" anchor="ctr"/>
+          <a:lstStyle/>
+          <a:p>
+            <a:pPr indent="0" marL="0">
+              <a:buNone/>
+            </a:pPr>
+            <a:r>
+              <a:rPr lang="en-US" sz="4400" b="1" dirty="0">
+                <a:solidFill>
+                  <a:srgbClr val="2A9D8F"/>
+                </a:solidFill>
+                <a:latin typeface="Cambria" pitchFamily="34" charset="0"/>
+                <a:ea typeface="Cambria" pitchFamily="34" charset="-122"/>
+                <a:cs typeface="Cambria" pitchFamily="34" charset="-120"/>
+              </a:rPr>
+              <a:t>$75</a:t>
+            </a:r>
+            <a:endParaRPr lang="en-US" sz="4400" dirty="0"/>
+          </a:p>
+        </p:txBody>
+      </p:sp>
+      <p:sp>
+        <p:nvSpPr>
+          <p:cNvPr id="6" name="Text 4"/>
+          <p:cNvSpPr txBox="1"/>
+          <p:nvPr/>
+        </p:nvSpPr>
+        <p:spPr>
+          <a:xfrm>
+            <a:off x="548640" y="2377440"/>
+            <a:ext cx="3474720" cy="640080"/>
+          </a:xfrm>
+          <a:prstGeom prst="rect">
+            <a:avLst/>
+          </a:prstGeom>
+          <a:noFill/>
+          <a:ln/>
+        </p:spPr>
+        <p:txBody>
+          <a:bodyPr wrap="square" lIns="0" tIns="0" rIns="0" bIns="0" rtlCol="0" anchor="t"/>
+          <a:lstStyle/>
+          <a:p>
+            <a:pPr indent="0" marL="0">
+              <a:buNone/>
+            </a:pPr>
+            <a:r>
+              <a:rPr lang="en-US" sz="1300" dirty="0">
+                <a:solidFill>
+                  <a:srgbClr val="1B2733"/>
+                </a:solidFill>
+                <a:latin typeface="Calibri" pitchFamily="34" charset="0"/>
+                <a:ea typeface="Calibri" pitchFamily="34" charset="-122"/>
+                <a:cs typeface="Calibri" pitchFamily="34" charset="-120"/>
+              </a:rPr>
+              <a:t>per month of model usage at 1,000 reviews a day</a:t>
+            </a:r>
+            <a:endParaRPr lang="en-US" sz="1300" dirty="0"/>
+          </a:p>
+        </p:txBody>
+      </p:sp>
+      <p:sp>
+        <p:nvSpPr>
+          <p:cNvPr id="7" name="Text 5"/>
+          <p:cNvSpPr txBox="1"/>
+          <p:nvPr/>
+        </p:nvSpPr>
+        <p:spPr>
+          <a:xfrm>
+            <a:off x="4297680" y="1554480"/>
+            <a:ext cx="3474720" cy="822960"/>
+          </a:xfrm>
+          <a:prstGeom prst="rect">
+            <a:avLst/>
+          </a:prstGeom>
+          <a:noFill/>
+          <a:ln/>
+        </p:spPr>
+        <p:txBody>
+          <a:bodyPr wrap="square" lIns="0" tIns="0" rIns="0" bIns="0" rtlCol="0" anchor="ctr"/>
+          <a:lstStyle/>
+          <a:p>
+            <a:pPr indent="0" marL="0">
+              <a:buNone/>
+            </a:pPr>
+            <a:r>
+              <a:rPr lang="en-US" sz="4400" b="1" dirty="0">
+                <a:solidFill>
+                  <a:srgbClr val="1F3A5F"/>
+                </a:solidFill>
+                <a:latin typeface="Cambria" pitchFamily="34" charset="0"/>
+                <a:ea typeface="Cambria" pitchFamily="34" charset="-122"/>
+                <a:cs typeface="Cambria" pitchFamily="34" charset="-120"/>
+              </a:rPr>
+              <a:t>11 min</a:t>
+            </a:r>
+            <a:endParaRPr lang="en-US" sz="4400" dirty="0"/>
+          </a:p>
+        </p:txBody>
+      </p:sp>
+      <p:sp>
+        <p:nvSpPr>
+          <p:cNvPr id="8" name="Text 6"/>
+          <p:cNvSpPr txBox="1"/>
+          <p:nvPr/>
+        </p:nvSpPr>
+        <p:spPr>
+          <a:xfrm>
+            <a:off x="4297680" y="2377440"/>
+            <a:ext cx="3474720" cy="640080"/>
+          </a:xfrm>
+          <a:prstGeom prst="rect">
+            <a:avLst/>
+          </a:prstGeom>
+          <a:noFill/>
+          <a:ln/>
+        </p:spPr>
+        <p:txBody>
+          <a:bodyPr wrap="square" lIns="0" tIns="0" rIns="0" bIns="0" rtlCol="0" anchor="t"/>
+          <a:lstStyle/>
+          <a:p>
+            <a:pPr indent="0" marL="0">
+              <a:buNone/>
+            </a:pPr>
+            <a:r>
+              <a:rPr lang="en-US" sz="1300" dirty="0">
+                <a:solidFill>
+                  <a:srgbClr val="1B2733"/>
+                </a:solidFill>
+                <a:latin typeface="Calibri" pitchFamily="34" charset="0"/>
+                <a:ea typeface="Calibri" pitchFamily="34" charset="-122"/>
+                <a:cs typeface="Calibri" pitchFamily="34" charset="-120"/>
+              </a:rPr>
+              <a:t>of automated processing for a day's 1,000 reviews</a:t>
+            </a:r>
+            <a:endParaRPr lang="en-US" sz="1300" dirty="0"/>
+          </a:p>
+        </p:txBody>
+      </p:sp>
+      <p:sp>
+        <p:nvSpPr>
+          <p:cNvPr id="9" name="Text 7"/>
+          <p:cNvSpPr txBox="1"/>
+          <p:nvPr/>
+        </p:nvSpPr>
+        <p:spPr>
+          <a:xfrm>
+            <a:off x="8046720" y="1554480"/>
+            <a:ext cx="3566160" cy="822960"/>
+          </a:xfrm>
+          <a:prstGeom prst="rect">
+            <a:avLst/>
+          </a:prstGeom>
+          <a:noFill/>
+          <a:ln/>
+        </p:spPr>
+        <p:txBody>
+          <a:bodyPr wrap="square" lIns="0" tIns="0" rIns="0" bIns="0" rtlCol="0" anchor="ctr"/>
+          <a:lstStyle/>
+          <a:p>
+            <a:pPr indent="0" marL="0">
+              <a:buNone/>
+            </a:pPr>
+            <a:r>
+              <a:rPr lang="en-US" sz="4400" b="1" dirty="0">
+                <a:solidFill>
+                  <a:srgbClr val="E9A23B"/>
+                </a:solidFill>
+                <a:latin typeface="Cambria" pitchFamily="34" charset="0"/>
+                <a:ea typeface="Cambria" pitchFamily="34" charset="-122"/>
+                <a:cs typeface="Cambria" pitchFamily="34" charset="-120"/>
+              </a:rPr>
+              <a:t>~33 h</a:t>
+            </a:r>
+            <a:endParaRPr lang="en-US" sz="4400" dirty="0"/>
+          </a:p>
+        </p:txBody>
+      </p:sp>
+      <p:sp>
+        <p:nvSpPr>
+          <p:cNvPr id="10" name="Text 8"/>
+          <p:cNvSpPr txBox="1"/>
+          <p:nvPr/>
+        </p:nvSpPr>
+        <p:spPr>
+          <a:xfrm>
+            <a:off x="8046720" y="2377440"/>
+            <a:ext cx="3566160" cy="640080"/>
+          </a:xfrm>
+          <a:prstGeom prst="rect">
+            <a:avLst/>
+          </a:prstGeom>
+          <a:noFill/>
+          <a:ln/>
+        </p:spPr>
+        <p:txBody>
+          <a:bodyPr wrap="square" lIns="0" tIns="0" rIns="0" bIns="0" rtlCol="0" anchor="t"/>
+          <a:lstStyle/>
+          <a:p>
+            <a:pPr indent="0" marL="0">
+              <a:buNone/>
+            </a:pPr>
+            <a:r>
+              <a:rPr lang="en-US" sz="1300" dirty="0">
+                <a:solidFill>
+                  <a:srgbClr val="1B2733"/>
+                </a:solidFill>
+                <a:latin typeface="Calibri" pitchFamily="34" charset="0"/>
+                <a:ea typeface="Calibri" pitchFamily="34" charset="-122"/>
+                <a:cs typeface="Calibri" pitchFamily="34" charset="-120"/>
+              </a:rPr>
+              <a:t>of manual work for the same reviews at 2 min each (assumption)</a:t>
+            </a:r>
+            <a:endParaRPr lang="en-US" sz="1300" dirty="0"/>
+          </a:p>
+        </p:txBody>
+      </p:sp>
+      <p:sp>
+        <p:nvSpPr>
+          <p:cNvPr id="11" name="Shape 9"/>
+          <p:cNvSpPr/>
+          <p:nvPr/>
+        </p:nvSpPr>
+        <p:spPr>
+          <a:xfrm>
+            <a:off x="548640" y="3566160"/>
+            <a:ext cx="5394960" cy="2606040"/>
+          </a:xfrm>
+          <a:prstGeom prst="roundRect">
+            <a:avLst>
+              <a:gd name="adj" fmla="val 3509"/>
+            </a:avLst>
+          </a:prstGeom>
+          <a:solidFill>
+            <a:srgbClr val="EEF2F7"/>
+          </a:solidFill>
+          <a:ln w="12700">
+            <a:solidFill>
+              <a:srgbClr val="EEF2F7"/>
+            </a:solidFill>
+            <a:prstDash val="solid"/>
+          </a:ln>
+        </p:spPr>
+      </p:sp>
+      <p:sp>
+        <p:nvSpPr>
+          <p:cNvPr id="12" name="Text 10"/>
+          <p:cNvSpPr txBox="1"/>
+          <p:nvPr/>
+        </p:nvSpPr>
+        <p:spPr>
+          <a:xfrm>
+            <a:off x="731520" y="3703320"/>
+            <a:ext cx="5029200" cy="365760"/>
+          </a:xfrm>
+          <a:prstGeom prst="rect">
+            <a:avLst/>
+          </a:prstGeom>
+          <a:noFill/>
+          <a:ln/>
+        </p:spPr>
+        <p:txBody>
+          <a:bodyPr wrap="square" lIns="0" tIns="0" rIns="0" bIns="0" rtlCol="0" anchor="t"/>
+          <a:lstStyle/>
+          <a:p>
+            <a:pPr indent="0" marL="0">
+              <a:buNone/>
+            </a:pPr>
+            <a:r>
+              <a:rPr lang="en-US" sz="1600" b="1" dirty="0">
+                <a:solidFill>
+                  <a:srgbClr val="1F3A5F"/>
+                </a:solidFill>
+                <a:latin typeface="Cambria" pitchFamily="34" charset="0"/>
+                <a:ea typeface="Cambria" pitchFamily="34" charset="-122"/>
+                <a:cs typeface="Cambria" pitchFamily="34" charset="-120"/>
+              </a:rPr>
+              <a:t>Value</a:t>
+            </a:r>
+            <a:endParaRPr lang="en-US" sz="1600" dirty="0"/>
+          </a:p>
+        </p:txBody>
+      </p:sp>
+      <p:sp>
+        <p:nvSpPr>
+          <p:cNvPr id="13" name="Text 11"/>
+          <p:cNvSpPr txBox="1"/>
+          <p:nvPr/>
+        </p:nvSpPr>
+        <p:spPr>
+          <a:xfrm>
+            <a:off x="731520" y="4114800"/>
+            <a:ext cx="5029200" cy="1920240"/>
+          </a:xfrm>
+          <a:prstGeom prst="rect">
+            <a:avLst/>
+          </a:prstGeom>
+          <a:noFill/>
+          <a:ln/>
+        </p:spPr>
+        <p:txBody>
+          <a:bodyPr wrap="square" lIns="0" tIns="0" rIns="0" bIns="0" rtlCol="0" anchor="t"/>
+          <a:lstStyle/>
+          <a:p>
+            <a:pPr marL="342900" indent="-342900">
+              <a:spcAft>
+                <a:spcPts val="800"/>
+              </a:spcAft>
+              <a:buSzPct val="100000"/>
+              <a:buChar char="•"/>
+            </a:pPr>
+            <a:r>
+              <a:rPr lang="en-US" sz="1600" dirty="0">
+                <a:solidFill>
+                  <a:srgbClr val="1B2733"/>
+                </a:solidFill>
+                <a:latin typeface="Calibri" pitchFamily="34" charset="0"/>
+                <a:ea typeface="Calibri" pitchFamily="34" charset="-122"/>
+                <a:cs typeface="Calibri" pitchFamily="34" charset="-120"/>
+              </a:rPr>
+              <a:t>Replies in the customer's own language</a:t>
+            </a:r>
+            <a:endParaRPr lang="en-US" sz="1300" dirty="0"/>
+          </a:p>
+          <a:p>
+            <a:pPr marL="342900" indent="-342900">
+              <a:spcAft>
+                <a:spcPts val="800"/>
+              </a:spcAft>
+              <a:buSzPct val="100000"/>
+              <a:buChar char="•"/>
+            </a:pPr>
+            <a:r>
+              <a:rPr lang="en-US" sz="1600" dirty="0">
+                <a:solidFill>
+                  <a:srgbClr val="1B2733"/>
+                </a:solidFill>
+                <a:latin typeface="Calibri" pitchFamily="34" charset="0"/>
+                <a:ea typeface="Calibri" pitchFamily="34" charset="-122"/>
+                <a:cs typeface="Calibri" pitchFamily="34" charset="-120"/>
+              </a:rPr>
+              <a:t>Early warning on delivery, packaging and price problems</a:t>
+            </a:r>
+            <a:endParaRPr lang="en-US" sz="1300" dirty="0"/>
+          </a:p>
+          <a:p>
+            <a:pPr marL="342900" indent="-342900">
+              <a:spcAft>
+                <a:spcPts val="800"/>
+              </a:spcAft>
+              <a:buSzPct val="100000"/>
+              <a:buChar char="•"/>
+            </a:pPr>
+            <a:r>
+              <a:rPr lang="en-US" sz="1600" dirty="0">
+                <a:solidFill>
+                  <a:srgbClr val="1B2733"/>
+                </a:solidFill>
+                <a:latin typeface="Calibri" pitchFamily="34" charset="0"/>
+                <a:ea typeface="Calibri" pitchFamily="34" charset="-122"/>
+                <a:cs typeface="Calibri" pitchFamily="34" charset="-120"/>
+              </a:rPr>
+              <a:t>Shared view of why customers rate low</a:t>
+            </a:r>
+            <a:endParaRPr lang="en-US" sz="1300" dirty="0"/>
+          </a:p>
+        </p:txBody>
+      </p:sp>
+      <p:sp>
+        <p:nvSpPr>
+          <p:cNvPr id="14" name="Shape 12"/>
+          <p:cNvSpPr/>
+          <p:nvPr/>
+        </p:nvSpPr>
+        <p:spPr>
+          <a:xfrm>
+            <a:off x="6217920" y="3566160"/>
+            <a:ext cx="5394960" cy="2606040"/>
+          </a:xfrm>
+          <a:prstGeom prst="roundRect">
+            <a:avLst>
+              <a:gd name="adj" fmla="val 3509"/>
+            </a:avLst>
+          </a:prstGeom>
+          <a:solidFill>
+            <a:srgbClr val="EEF2F7"/>
+          </a:solidFill>
+          <a:ln w="12700">
+            <a:solidFill>
+              <a:srgbClr val="EEF2F7"/>
+            </a:solidFill>
+            <a:prstDash val="solid"/>
+          </a:ln>
+        </p:spPr>
+      </p:sp>
+      <p:sp>
+        <p:nvSpPr>
+          <p:cNvPr id="15" name="Text 13"/>
+          <p:cNvSpPr txBox="1"/>
+          <p:nvPr/>
+        </p:nvSpPr>
+        <p:spPr>
+          <a:xfrm>
+            <a:off x="6400800" y="3703320"/>
+            <a:ext cx="5029200" cy="365760"/>
+          </a:xfrm>
+          <a:prstGeom prst="rect">
+            <a:avLst/>
+          </a:prstGeom>
+          <a:noFill/>
+          <a:ln/>
+        </p:spPr>
+        <p:txBody>
+          <a:bodyPr wrap="square" lIns="0" tIns="0" rIns="0" bIns="0" rtlCol="0" anchor="t"/>
+          <a:lstStyle/>
+          <a:p>
+            <a:pPr indent="0" marL="0">
+              <a:buNone/>
+            </a:pPr>
+            <a:r>
+              <a:rPr lang="en-US" sz="1600" b="1" dirty="0">
+                <a:solidFill>
+                  <a:srgbClr val="1F3A5F"/>
+                </a:solidFill>
+                <a:latin typeface="Cambria" pitchFamily="34" charset="0"/>
+                <a:ea typeface="Cambria" pitchFamily="34" charset="-122"/>
+                <a:cs typeface="Cambria" pitchFamily="34" charset="-120"/>
+              </a:rPr>
+              <a:t>Risks we manage</a:t>
+            </a:r>
+            <a:endParaRPr lang="en-US" sz="1600" dirty="0"/>
+          </a:p>
+        </p:txBody>
+      </p:sp>
+      <p:sp>
+        <p:nvSpPr>
+          <p:cNvPr id="16" name="Text 14"/>
+          <p:cNvSpPr txBox="1"/>
+          <p:nvPr/>
+        </p:nvSpPr>
+        <p:spPr>
+          <a:xfrm>
+            <a:off x="6400800" y="4114800"/>
+            <a:ext cx="5029200" cy="1920240"/>
+          </a:xfrm>
+          <a:prstGeom prst="rect">
+            <a:avLst/>
+          </a:prstGeom>
+          <a:noFill/>
+          <a:ln/>
+        </p:spPr>
+        <p:txBody>
+          <a:bodyPr wrap="square" lIns="0" tIns="0" rIns="0" bIns="0" rtlCol="0" anchor="t"/>
+          <a:lstStyle/>
+          <a:p>
+            <a:pPr marL="342900" indent="-342900">
+              <a:spcAft>
+                <a:spcPts val="800"/>
+              </a:spcAft>
+              <a:buSzPct val="100000"/>
+              <a:buChar char="•"/>
+            </a:pPr>
+            <a:r>
+              <a:rPr lang="en-US" sz="1600" dirty="0">
+                <a:solidFill>
+                  <a:srgbClr val="1B2733"/>
+                </a:solidFill>
+                <a:latin typeface="Calibri" pitchFamily="34" charset="0"/>
+                <a:ea typeface="Calibri" pitchFamily="34" charset="-122"/>
+                <a:cs typeface="Calibri" pitchFamily="34" charset="-120"/>
+              </a:rPr>
+              <a:t>Over-promising replies: guardrails, judge, human approval</a:t>
+            </a:r>
+            <a:endParaRPr lang="en-US" sz="1300" dirty="0"/>
+          </a:p>
+          <a:p>
+            <a:pPr marL="342900" indent="-342900">
+              <a:spcAft>
+                <a:spcPts val="800"/>
+              </a:spcAft>
+              <a:buSzPct val="100000"/>
+              <a:buChar char="•"/>
+            </a:pPr>
+            <a:r>
+              <a:rPr lang="en-US" sz="1600" dirty="0">
+                <a:solidFill>
+                  <a:srgbClr val="1B2733"/>
+                </a:solidFill>
+                <a:latin typeface="Calibri" pitchFamily="34" charset="0"/>
+                <a:ea typeface="Calibri" pitchFamily="34" charset="-122"/>
+                <a:cs typeface="Calibri" pitchFamily="34" charset="-120"/>
+              </a:rPr>
+              <a:t>Cost surprises: spend cap and call log</a:t>
+            </a:r>
+            <a:endParaRPr lang="en-US" sz="1300" dirty="0"/>
+          </a:p>
+          <a:p>
+            <a:pPr marL="342900" indent="-342900">
+              <a:spcAft>
+                <a:spcPts val="800"/>
+              </a:spcAft>
+              <a:buSzPct val="100000"/>
+              <a:buChar char="•"/>
+            </a:pPr>
+            <a:r>
+              <a:rPr lang="en-US" sz="1600" dirty="0">
+                <a:solidFill>
+                  <a:srgbClr val="1B2733"/>
+                </a:solidFill>
+                <a:latin typeface="Calibri" pitchFamily="34" charset="0"/>
+                <a:ea typeface="Calibri" pitchFamily="34" charset="-122"/>
+                <a:cs typeface="Calibri" pitchFamily="34" charset="-120"/>
+              </a:rPr>
+              <a:t>Weak neutral sentiment: flag borderline reviews</a:t>
+            </a:r>
+            <a:endParaRPr lang="en-US" sz="1300" dirty="0"/>
+          </a:p>
+        </p:txBody>
+      </p:sp>
+      <p:sp>
+        <p:nvSpPr>
+          <p:cNvPr id="25" name="Slide Number Placeholder 0"/>
+          <p:cNvSpPr>
+            <a:spLocks noGrp="1"/>
+          </p:cNvSpPr>
+          <p:nvPr>
+            <p:ph type="sldNum" sz="quarter" idx="4294967295"/>
+          </p:nvPr>
+        </p:nvSpPr>
+        <p:spPr>
+          <a:xfrm>
+            <a:off x="11155680" y="6446520"/>
+            <a:ext cx="548640" cy="274320"/>
+          </a:xfrm>
+          <a:prstGeom prst="rect">
+            <a:avLst/>
+          </a:prstGeom>
+          <a:extLst>
+            <a:ext uri="{C572A759-6A51-4108-AA02-DFA0A04FC94B}">
+              <ma14:wrappingTextBoxFlag xmlns:ma14="http://schemas.microsoft.com/office/mac/drawingml/2011/main" val="0"/>
+            </a:ext>
+          </a:extLst>
+        </p:spPr>
+        <p:txBody>
+          <a:bodyPr/>
+          <a:lstStyle>
+            <a:lvl1pPr>
+              <a:defRPr sz="1000">
+                <a:solidFill>
+                  <a:srgbClr val="5A6470"/>
+                </a:solidFill>
+                <a:latin typeface="Calibri"/>
+                <a:ea typeface="Calibri"/>
+                <a:cs typeface="Calibri"/>
+              </a:defRPr>
+            </a:lvl1pPr>
+          </a:lstStyle>
+          <a:p>
+            <a:pPr algn="r"/>
+            <a:fld id="{F7021451-1387-4CA6-816F-3879F97B5CBC}" type="slidenum">
+              <a:rPr b="0" lang="en-US"/>
+              <a:t>20</a:t>
+            </a:fld>
+            <a:endParaRPr lang="en-US"/>
+          </a:p>
+        </p:txBody>
+      </p:sp>
+    </p:spTree>
+  </p:cSld>
+  <p:clrMapOvr>
+    <a:masterClrMapping/>
+  </p:clrMapOvr>
+</p:sld>
+</file>
+
+<file path=ppt/slides/slide21.xml><?xml version="1.0" encoding="utf-8"?>
+<p:sld xmlns:a="http://schemas.openxmlformats.org/drawingml/2006/main" xmlns:r="http://schemas.openxmlformats.org/officeDocument/2006/relationships" xmlns:p="http://schemas.openxmlformats.org/presentationml/2006/main">
+  <p:cSld name="Slide 21">
     <p:bg>
       <p:bgPr>
         <a:solidFill>

</xml_diff>